<commit_message>
Fixed time table and title defense slides
</commit_message>
<xml_diff>
--- a/Slides/canteen title defense.pptx
+++ b/Slides/canteen title defense.pptx
@@ -270,7 +270,7 @@
           <a:p>
             <a:fld id="{441AD79C-955D-496E-B1A6-D3F877A4C76A}" type="datetimeFigureOut">
               <a:rPr lang="en-US" smtClean="0"/>
-              <a:t>4/28/2026</a:t>
+              <a:t>4/29/2026</a:t>
             </a:fld>
             <a:endParaRPr lang="en-US"/>
           </a:p>
@@ -468,7 +468,7 @@
           <a:p>
             <a:fld id="{441AD79C-955D-496E-B1A6-D3F877A4C76A}" type="datetimeFigureOut">
               <a:rPr lang="en-US" smtClean="0"/>
-              <a:t>4/28/2026</a:t>
+              <a:t>4/29/2026</a:t>
             </a:fld>
             <a:endParaRPr lang="en-US"/>
           </a:p>
@@ -676,7 +676,7 @@
           <a:p>
             <a:fld id="{441AD79C-955D-496E-B1A6-D3F877A4C76A}" type="datetimeFigureOut">
               <a:rPr lang="en-US" smtClean="0"/>
-              <a:t>4/28/2026</a:t>
+              <a:t>4/29/2026</a:t>
             </a:fld>
             <a:endParaRPr lang="en-US"/>
           </a:p>
@@ -874,7 +874,7 @@
           <a:p>
             <a:fld id="{441AD79C-955D-496E-B1A6-D3F877A4C76A}" type="datetimeFigureOut">
               <a:rPr lang="en-US" smtClean="0"/>
-              <a:t>4/28/2026</a:t>
+              <a:t>4/29/2026</a:t>
             </a:fld>
             <a:endParaRPr lang="en-US"/>
           </a:p>
@@ -1149,7 +1149,7 @@
           <a:p>
             <a:fld id="{441AD79C-955D-496E-B1A6-D3F877A4C76A}" type="datetimeFigureOut">
               <a:rPr lang="en-US" smtClean="0"/>
-              <a:t>4/28/2026</a:t>
+              <a:t>4/29/2026</a:t>
             </a:fld>
             <a:endParaRPr lang="en-US"/>
           </a:p>
@@ -1414,7 +1414,7 @@
           <a:p>
             <a:fld id="{441AD79C-955D-496E-B1A6-D3F877A4C76A}" type="datetimeFigureOut">
               <a:rPr lang="en-US" smtClean="0"/>
-              <a:t>4/28/2026</a:t>
+              <a:t>4/29/2026</a:t>
             </a:fld>
             <a:endParaRPr lang="en-US"/>
           </a:p>
@@ -1826,7 +1826,7 @@
           <a:p>
             <a:fld id="{441AD79C-955D-496E-B1A6-D3F877A4C76A}" type="datetimeFigureOut">
               <a:rPr lang="en-US" smtClean="0"/>
-              <a:t>4/28/2026</a:t>
+              <a:t>4/29/2026</a:t>
             </a:fld>
             <a:endParaRPr lang="en-US"/>
           </a:p>
@@ -1967,7 +1967,7 @@
           <a:p>
             <a:fld id="{441AD79C-955D-496E-B1A6-D3F877A4C76A}" type="datetimeFigureOut">
               <a:rPr lang="en-US" smtClean="0"/>
-              <a:t>4/28/2026</a:t>
+              <a:t>4/29/2026</a:t>
             </a:fld>
             <a:endParaRPr lang="en-US"/>
           </a:p>
@@ -2080,7 +2080,7 @@
           <a:p>
             <a:fld id="{441AD79C-955D-496E-B1A6-D3F877A4C76A}" type="datetimeFigureOut">
               <a:rPr lang="en-US" smtClean="0"/>
-              <a:t>4/28/2026</a:t>
+              <a:t>4/29/2026</a:t>
             </a:fld>
             <a:endParaRPr lang="en-US"/>
           </a:p>
@@ -2391,7 +2391,7 @@
           <a:p>
             <a:fld id="{441AD79C-955D-496E-B1A6-D3F877A4C76A}" type="datetimeFigureOut">
               <a:rPr lang="en-US" smtClean="0"/>
-              <a:t>4/28/2026</a:t>
+              <a:t>4/29/2026</a:t>
             </a:fld>
             <a:endParaRPr lang="en-US"/>
           </a:p>
@@ -2679,7 +2679,7 @@
           <a:p>
             <a:fld id="{441AD79C-955D-496E-B1A6-D3F877A4C76A}" type="datetimeFigureOut">
               <a:rPr lang="en-US" smtClean="0"/>
-              <a:t>4/28/2026</a:t>
+              <a:t>4/29/2026</a:t>
             </a:fld>
             <a:endParaRPr lang="en-US"/>
           </a:p>
@@ -2920,7 +2920,7 @@
           <a:p>
             <a:fld id="{441AD79C-955D-496E-B1A6-D3F877A4C76A}" type="datetimeFigureOut">
               <a:rPr lang="en-US" smtClean="0"/>
-              <a:t>4/28/2026</a:t>
+              <a:t>4/29/2026</a:t>
             </a:fld>
             <a:endParaRPr lang="en-US"/>
           </a:p>
@@ -3717,38 +3717,2982 @@
           </a:p>
         </p:txBody>
       </p:sp>
-      <p:pic>
-        <p:nvPicPr>
-          <p:cNvPr id="5" name="Content Placeholder 4">
-            <a:extLst>
-              <a:ext uri="{FF2B5EF4-FFF2-40B4-BE49-F238E27FC236}">
-                <a16:creationId xmlns:a16="http://schemas.microsoft.com/office/drawing/2014/main" id="{FE890E17-D4E7-4A8A-96F3-E2B6664A13C4}"/>
-              </a:ext>
-            </a:extLst>
-          </p:cNvPr>
-          <p:cNvPicPr>
-            <a:picLocks noGrp="1" noChangeAspect="1"/>
-          </p:cNvPicPr>
+      <p:graphicFrame>
+        <p:nvGraphicFramePr>
+          <p:cNvPr id="6" name="Content Placeholder 5">
+            <a:extLst>
+              <a:ext uri="{FF2B5EF4-FFF2-40B4-BE49-F238E27FC236}">
+                <a16:creationId xmlns:a16="http://schemas.microsoft.com/office/drawing/2014/main" id="{19E4B716-5E88-722F-FEE9-2BCDCA72FE5C}"/>
+              </a:ext>
+            </a:extLst>
+          </p:cNvPr>
+          <p:cNvGraphicFramePr>
+            <a:graphicFrameLocks noGrp="1"/>
+          </p:cNvGraphicFramePr>
           <p:nvPr>
             <p:ph idx="1"/>
-          </p:nvPr>
-        </p:nvPicPr>
-        <p:blipFill>
-          <a:blip r:embed="rId2"/>
-          <a:stretch>
-            <a:fillRect/>
-          </a:stretch>
-        </p:blipFill>
-        <p:spPr>
-          <a:xfrm>
-            <a:off x="907026" y="1223449"/>
-            <a:ext cx="9407653" cy="5373995"/>
-          </a:xfrm>
-          <a:prstGeom prst="rect">
-            <a:avLst/>
-          </a:prstGeom>
-        </p:spPr>
-      </p:pic>
+            <p:extLst>
+              <p:ext uri="{D42A27DB-BD31-4B8C-83A1-F6EECF244321}">
+                <p14:modId xmlns:p14="http://schemas.microsoft.com/office/powerpoint/2010/main" val="3987349814"/>
+              </p:ext>
+            </p:extLst>
+          </p:nvPr>
+        </p:nvGraphicFramePr>
+        <p:xfrm>
+          <a:off x="1001949" y="1040860"/>
+          <a:ext cx="10700425" cy="5583668"/>
+        </p:xfrm>
+        <a:graphic>
+          <a:graphicData uri="http://schemas.openxmlformats.org/drawingml/2006/table">
+            <a:tbl>
+              <a:tblPr>
+                <a:tableStyleId>{5C22544A-7EE6-4342-B048-85BDC9FD1C3A}</a:tableStyleId>
+              </a:tblPr>
+              <a:tblGrid>
+                <a:gridCol w="803788">
+                  <a:extLst>
+                    <a:ext uri="{9D8B030D-6E8A-4147-A177-3AD203B41FA5}">
+                      <a16:colId xmlns:a16="http://schemas.microsoft.com/office/drawing/2014/main" val="2887231879"/>
+                    </a:ext>
+                  </a:extLst>
+                </a:gridCol>
+                <a:gridCol w="5559532">
+                  <a:extLst>
+                    <a:ext uri="{9D8B030D-6E8A-4147-A177-3AD203B41FA5}">
+                      <a16:colId xmlns:a16="http://schemas.microsoft.com/office/drawing/2014/main" val="3954113466"/>
+                    </a:ext>
+                  </a:extLst>
+                </a:gridCol>
+                <a:gridCol w="1322901">
+                  <a:extLst>
+                    <a:ext uri="{9D8B030D-6E8A-4147-A177-3AD203B41FA5}">
+                      <a16:colId xmlns:a16="http://schemas.microsoft.com/office/drawing/2014/main" val="4065323800"/>
+                    </a:ext>
+                  </a:extLst>
+                </a:gridCol>
+                <a:gridCol w="1440120">
+                  <a:extLst>
+                    <a:ext uri="{9D8B030D-6E8A-4147-A177-3AD203B41FA5}">
+                      <a16:colId xmlns:a16="http://schemas.microsoft.com/office/drawing/2014/main" val="1598175862"/>
+                    </a:ext>
+                  </a:extLst>
+                </a:gridCol>
+                <a:gridCol w="1574084">
+                  <a:extLst>
+                    <a:ext uri="{9D8B030D-6E8A-4147-A177-3AD203B41FA5}">
+                      <a16:colId xmlns:a16="http://schemas.microsoft.com/office/drawing/2014/main" val="1543798223"/>
+                    </a:ext>
+                  </a:extLst>
+                </a:gridCol>
+              </a:tblGrid>
+              <a:tr h="236442">
+                <a:tc>
+                  <a:txBody>
+                    <a:bodyPr/>
+                    <a:lstStyle/>
+                    <a:p>
+                      <a:pPr algn="ctr" fontAlgn="ctr">
+                        <a:buNone/>
+                      </a:pPr>
+                      <a:r>
+                        <a:rPr lang="en-US" sz="1100" u="none" strike="noStrike">
+                          <a:effectLst/>
+                        </a:rPr>
+                        <a:t>Task Id</a:t>
+                      </a:r>
+                      <a:endParaRPr lang="en-US" sz="1100" b="1" i="0" u="none" strike="noStrike">
+                        <a:solidFill>
+                          <a:srgbClr val="000000"/>
+                        </a:solidFill>
+                        <a:effectLst/>
+                        <a:latin typeface="Times New Roman" panose="02020603050405020304" pitchFamily="18" charset="0"/>
+                      </a:endParaRPr>
+                    </a:p>
+                  </a:txBody>
+                  <a:tcPr marL="7087" marR="7087" marT="7087" marB="0" anchor="ctr"/>
+                </a:tc>
+                <a:tc>
+                  <a:txBody>
+                    <a:bodyPr/>
+                    <a:lstStyle/>
+                    <a:p>
+                      <a:pPr algn="ctr" fontAlgn="ctr">
+                        <a:buNone/>
+                      </a:pPr>
+                      <a:r>
+                        <a:rPr lang="en-US" sz="1100" u="none" strike="noStrike">
+                          <a:effectLst/>
+                        </a:rPr>
+                        <a:t>Task Name</a:t>
+                      </a:r>
+                      <a:endParaRPr lang="en-US" sz="1100" b="1" i="0" u="none" strike="noStrike">
+                        <a:solidFill>
+                          <a:srgbClr val="000000"/>
+                        </a:solidFill>
+                        <a:effectLst/>
+                        <a:latin typeface="Times New Roman" panose="02020603050405020304" pitchFamily="18" charset="0"/>
+                      </a:endParaRPr>
+                    </a:p>
+                  </a:txBody>
+                  <a:tcPr marL="7087" marR="7087" marT="7087" marB="0" anchor="ctr"/>
+                </a:tc>
+                <a:tc>
+                  <a:txBody>
+                    <a:bodyPr/>
+                    <a:lstStyle/>
+                    <a:p>
+                      <a:pPr algn="ctr" fontAlgn="ctr">
+                        <a:buNone/>
+                      </a:pPr>
+                      <a:r>
+                        <a:rPr lang="en-US" sz="1100" u="none" strike="noStrike">
+                          <a:effectLst/>
+                        </a:rPr>
+                        <a:t>Start Date</a:t>
+                      </a:r>
+                      <a:endParaRPr lang="en-US" sz="1100" b="1" i="0" u="none" strike="noStrike">
+                        <a:solidFill>
+                          <a:srgbClr val="000000"/>
+                        </a:solidFill>
+                        <a:effectLst/>
+                        <a:latin typeface="Times New Roman" panose="02020603050405020304" pitchFamily="18" charset="0"/>
+                      </a:endParaRPr>
+                    </a:p>
+                  </a:txBody>
+                  <a:tcPr marL="7087" marR="7087" marT="7087" marB="0" anchor="ctr"/>
+                </a:tc>
+                <a:tc>
+                  <a:txBody>
+                    <a:bodyPr/>
+                    <a:lstStyle/>
+                    <a:p>
+                      <a:pPr algn="ctr" fontAlgn="ctr">
+                        <a:buNone/>
+                      </a:pPr>
+                      <a:r>
+                        <a:rPr lang="en-US" sz="1100" u="none" strike="noStrike">
+                          <a:effectLst/>
+                        </a:rPr>
+                        <a:t>End Date</a:t>
+                      </a:r>
+                      <a:endParaRPr lang="en-US" sz="1100" b="1" i="0" u="none" strike="noStrike">
+                        <a:solidFill>
+                          <a:srgbClr val="000000"/>
+                        </a:solidFill>
+                        <a:effectLst/>
+                        <a:latin typeface="Times New Roman" panose="02020603050405020304" pitchFamily="18" charset="0"/>
+                      </a:endParaRPr>
+                    </a:p>
+                  </a:txBody>
+                  <a:tcPr marL="7087" marR="7087" marT="7087" marB="0" anchor="ctr"/>
+                </a:tc>
+                <a:tc>
+                  <a:txBody>
+                    <a:bodyPr/>
+                    <a:lstStyle/>
+                    <a:p>
+                      <a:pPr algn="ctr" fontAlgn="ctr">
+                        <a:buNone/>
+                      </a:pPr>
+                      <a:r>
+                        <a:rPr lang="en-US" sz="1100" u="none" strike="noStrike">
+                          <a:effectLst/>
+                        </a:rPr>
+                        <a:t>Duration(Days)</a:t>
+                      </a:r>
+                      <a:endParaRPr lang="en-US" sz="1100" b="1" i="0" u="none" strike="noStrike">
+                        <a:solidFill>
+                          <a:srgbClr val="000000"/>
+                        </a:solidFill>
+                        <a:effectLst/>
+                        <a:latin typeface="Times New Roman" panose="02020603050405020304" pitchFamily="18" charset="0"/>
+                      </a:endParaRPr>
+                    </a:p>
+                  </a:txBody>
+                  <a:tcPr marL="7087" marR="7087" marT="7087" marB="0" anchor="ctr"/>
+                </a:tc>
+                <a:extLst>
+                  <a:ext uri="{0D108BD9-81ED-4DB2-BD59-A6C34878D82A}">
+                    <a16:rowId xmlns:a16="http://schemas.microsoft.com/office/drawing/2014/main" val="3536282104"/>
+                  </a:ext>
+                </a:extLst>
+              </a:tr>
+              <a:tr h="236442">
+                <a:tc>
+                  <a:txBody>
+                    <a:bodyPr/>
+                    <a:lstStyle/>
+                    <a:p>
+                      <a:pPr algn="ctr" fontAlgn="ctr">
+                        <a:buNone/>
+                      </a:pPr>
+                      <a:r>
+                        <a:rPr lang="en-US" sz="1100" u="none" strike="noStrike">
+                          <a:effectLst/>
+                        </a:rPr>
+                        <a:t>1</a:t>
+                      </a:r>
+                      <a:endParaRPr lang="en-US" sz="1100" b="1" i="0" u="none" strike="noStrike">
+                        <a:solidFill>
+                          <a:srgbClr val="000000"/>
+                        </a:solidFill>
+                        <a:effectLst/>
+                        <a:latin typeface="Times New Roman" panose="02020603050405020304" pitchFamily="18" charset="0"/>
+                      </a:endParaRPr>
+                    </a:p>
+                  </a:txBody>
+                  <a:tcPr marL="7087" marR="7087" marT="7087" marB="0" anchor="ctr"/>
+                </a:tc>
+                <a:tc>
+                  <a:txBody>
+                    <a:bodyPr/>
+                    <a:lstStyle/>
+                    <a:p>
+                      <a:pPr algn="l" fontAlgn="ctr">
+                        <a:buNone/>
+                      </a:pPr>
+                      <a:r>
+                        <a:rPr lang="en-US" sz="1100" u="none" strike="noStrike">
+                          <a:effectLst/>
+                        </a:rPr>
+                        <a:t>Title Defense</a:t>
+                      </a:r>
+                      <a:endParaRPr lang="en-US" sz="1100" b="1" i="0" u="none" strike="noStrike">
+                        <a:solidFill>
+                          <a:srgbClr val="000000"/>
+                        </a:solidFill>
+                        <a:effectLst/>
+                        <a:latin typeface="Times New Roman" panose="02020603050405020304" pitchFamily="18" charset="0"/>
+                      </a:endParaRPr>
+                    </a:p>
+                  </a:txBody>
+                  <a:tcPr marL="63782" marR="7087" marT="7087" marB="0" anchor="ctr"/>
+                </a:tc>
+                <a:tc>
+                  <a:txBody>
+                    <a:bodyPr/>
+                    <a:lstStyle/>
+                    <a:p>
+                      <a:pPr algn="l" fontAlgn="b">
+                        <a:buNone/>
+                      </a:pPr>
+                      <a:r>
+                        <a:rPr lang="en-US" sz="1000" u="none" strike="noStrike">
+                          <a:effectLst/>
+                        </a:rPr>
+                        <a:t> </a:t>
+                      </a:r>
+                      <a:endParaRPr lang="en-US" sz="1000" b="0" i="0" u="none" strike="noStrike">
+                        <a:solidFill>
+                          <a:srgbClr val="000000"/>
+                        </a:solidFill>
+                        <a:effectLst/>
+                        <a:latin typeface="Aptos Narrow" panose="020B0004020202020204" pitchFamily="34" charset="0"/>
+                      </a:endParaRPr>
+                    </a:p>
+                  </a:txBody>
+                  <a:tcPr marL="63782" marR="7087" marT="7087" marB="0" anchor="b"/>
+                </a:tc>
+                <a:tc>
+                  <a:txBody>
+                    <a:bodyPr/>
+                    <a:lstStyle/>
+                    <a:p>
+                      <a:pPr algn="l" fontAlgn="b">
+                        <a:buNone/>
+                      </a:pPr>
+                      <a:r>
+                        <a:rPr lang="en-US" sz="1000" u="none" strike="noStrike">
+                          <a:effectLst/>
+                        </a:rPr>
+                        <a:t> </a:t>
+                      </a:r>
+                      <a:endParaRPr lang="en-US" sz="1000" b="0" i="0" u="none" strike="noStrike">
+                        <a:solidFill>
+                          <a:srgbClr val="000000"/>
+                        </a:solidFill>
+                        <a:effectLst/>
+                        <a:latin typeface="Aptos Narrow" panose="020B0004020202020204" pitchFamily="34" charset="0"/>
+                      </a:endParaRPr>
+                    </a:p>
+                  </a:txBody>
+                  <a:tcPr marL="63782" marR="7087" marT="7087" marB="0" anchor="b"/>
+                </a:tc>
+                <a:tc>
+                  <a:txBody>
+                    <a:bodyPr/>
+                    <a:lstStyle/>
+                    <a:p>
+                      <a:pPr algn="l" fontAlgn="b">
+                        <a:buNone/>
+                      </a:pPr>
+                      <a:r>
+                        <a:rPr lang="en-US" sz="1000" u="none" strike="noStrike">
+                          <a:effectLst/>
+                        </a:rPr>
+                        <a:t> </a:t>
+                      </a:r>
+                      <a:endParaRPr lang="en-US" sz="1000" b="0" i="0" u="none" strike="noStrike">
+                        <a:solidFill>
+                          <a:srgbClr val="000000"/>
+                        </a:solidFill>
+                        <a:effectLst/>
+                        <a:latin typeface="Aptos Narrow" panose="020B0004020202020204" pitchFamily="34" charset="0"/>
+                      </a:endParaRPr>
+                    </a:p>
+                  </a:txBody>
+                  <a:tcPr marL="63782" marR="7087" marT="7087" marB="0" anchor="b"/>
+                </a:tc>
+                <a:extLst>
+                  <a:ext uri="{0D108BD9-81ED-4DB2-BD59-A6C34878D82A}">
+                    <a16:rowId xmlns:a16="http://schemas.microsoft.com/office/drawing/2014/main" val="2540896613"/>
+                  </a:ext>
+                </a:extLst>
+              </a:tr>
+              <a:tr h="236442">
+                <a:tc>
+                  <a:txBody>
+                    <a:bodyPr/>
+                    <a:lstStyle/>
+                    <a:p>
+                      <a:pPr algn="ctr" fontAlgn="ctr">
+                        <a:buNone/>
+                      </a:pPr>
+                      <a:r>
+                        <a:rPr lang="en-US" sz="1100" u="none" strike="noStrike">
+                          <a:effectLst/>
+                        </a:rPr>
+                        <a:t>1.1</a:t>
+                      </a:r>
+                      <a:endParaRPr lang="en-US" sz="1100" b="0" i="0" u="none" strike="noStrike">
+                        <a:solidFill>
+                          <a:srgbClr val="000000"/>
+                        </a:solidFill>
+                        <a:effectLst/>
+                        <a:latin typeface="Times New Roman" panose="02020603050405020304" pitchFamily="18" charset="0"/>
+                      </a:endParaRPr>
+                    </a:p>
+                  </a:txBody>
+                  <a:tcPr marL="7087" marR="7087" marT="7087" marB="0" anchor="ctr"/>
+                </a:tc>
+                <a:tc>
+                  <a:txBody>
+                    <a:bodyPr/>
+                    <a:lstStyle/>
+                    <a:p>
+                      <a:pPr algn="l" fontAlgn="ctr">
+                        <a:buNone/>
+                      </a:pPr>
+                      <a:r>
+                        <a:rPr lang="en-US" sz="1100" u="none" strike="noStrike">
+                          <a:effectLst/>
+                        </a:rPr>
+                        <a:t>Topic Brainstorming</a:t>
+                      </a:r>
+                      <a:endParaRPr lang="en-US" sz="1100" b="0" i="0" u="none" strike="noStrike">
+                        <a:solidFill>
+                          <a:srgbClr val="000000"/>
+                        </a:solidFill>
+                        <a:effectLst/>
+                        <a:latin typeface="Times New Roman" panose="02020603050405020304" pitchFamily="18" charset="0"/>
+                      </a:endParaRPr>
+                    </a:p>
+                  </a:txBody>
+                  <a:tcPr marL="63782" marR="7087" marT="7087" marB="0" anchor="ctr"/>
+                </a:tc>
+                <a:tc>
+                  <a:txBody>
+                    <a:bodyPr/>
+                    <a:lstStyle/>
+                    <a:p>
+                      <a:pPr algn="ctr" fontAlgn="ctr">
+                        <a:buNone/>
+                      </a:pPr>
+                      <a:r>
+                        <a:rPr lang="en-US" sz="1100" u="none" strike="noStrike">
+                          <a:effectLst/>
+                        </a:rPr>
+                        <a:t>26-Apr</a:t>
+                      </a:r>
+                      <a:endParaRPr lang="en-US" sz="1100" b="0" i="0" u="none" strike="noStrike">
+                        <a:solidFill>
+                          <a:srgbClr val="000000"/>
+                        </a:solidFill>
+                        <a:effectLst/>
+                        <a:latin typeface="Times New Roman" panose="02020603050405020304" pitchFamily="18" charset="0"/>
+                      </a:endParaRPr>
+                    </a:p>
+                  </a:txBody>
+                  <a:tcPr marL="7087" marR="7087" marT="7087" marB="0" anchor="ctr"/>
+                </a:tc>
+                <a:tc>
+                  <a:txBody>
+                    <a:bodyPr/>
+                    <a:lstStyle/>
+                    <a:p>
+                      <a:pPr algn="ctr" fontAlgn="ctr">
+                        <a:buNone/>
+                      </a:pPr>
+                      <a:r>
+                        <a:rPr lang="en-US" sz="1100" u="none" strike="noStrike">
+                          <a:effectLst/>
+                        </a:rPr>
+                        <a:t>26-Apr</a:t>
+                      </a:r>
+                      <a:endParaRPr lang="en-US" sz="1100" b="0" i="0" u="none" strike="noStrike">
+                        <a:solidFill>
+                          <a:srgbClr val="000000"/>
+                        </a:solidFill>
+                        <a:effectLst/>
+                        <a:latin typeface="Times New Roman" panose="02020603050405020304" pitchFamily="18" charset="0"/>
+                      </a:endParaRPr>
+                    </a:p>
+                  </a:txBody>
+                  <a:tcPr marL="7087" marR="7087" marT="7087" marB="0" anchor="ctr"/>
+                </a:tc>
+                <a:tc>
+                  <a:txBody>
+                    <a:bodyPr/>
+                    <a:lstStyle/>
+                    <a:p>
+                      <a:pPr algn="ctr" fontAlgn="ctr">
+                        <a:buNone/>
+                      </a:pPr>
+                      <a:r>
+                        <a:rPr lang="en-US" sz="1100" u="none" strike="noStrike">
+                          <a:effectLst/>
+                        </a:rPr>
+                        <a:t>1</a:t>
+                      </a:r>
+                      <a:endParaRPr lang="en-US" sz="1100" b="0" i="0" u="none" strike="noStrike">
+                        <a:solidFill>
+                          <a:srgbClr val="000000"/>
+                        </a:solidFill>
+                        <a:effectLst/>
+                        <a:latin typeface="Times New Roman" panose="02020603050405020304" pitchFamily="18" charset="0"/>
+                      </a:endParaRPr>
+                    </a:p>
+                  </a:txBody>
+                  <a:tcPr marL="7087" marR="7087" marT="7087" marB="0" anchor="ctr"/>
+                </a:tc>
+                <a:extLst>
+                  <a:ext uri="{0D108BD9-81ED-4DB2-BD59-A6C34878D82A}">
+                    <a16:rowId xmlns:a16="http://schemas.microsoft.com/office/drawing/2014/main" val="429371993"/>
+                  </a:ext>
+                </a:extLst>
+              </a:tr>
+              <a:tr h="236442">
+                <a:tc>
+                  <a:txBody>
+                    <a:bodyPr/>
+                    <a:lstStyle/>
+                    <a:p>
+                      <a:pPr algn="ctr" fontAlgn="ctr">
+                        <a:buNone/>
+                      </a:pPr>
+                      <a:r>
+                        <a:rPr lang="en-US" sz="1100" u="none" strike="noStrike">
+                          <a:effectLst/>
+                        </a:rPr>
+                        <a:t>1.2</a:t>
+                      </a:r>
+                      <a:endParaRPr lang="en-US" sz="1100" b="0" i="0" u="none" strike="noStrike">
+                        <a:solidFill>
+                          <a:srgbClr val="000000"/>
+                        </a:solidFill>
+                        <a:effectLst/>
+                        <a:latin typeface="Times New Roman" panose="02020603050405020304" pitchFamily="18" charset="0"/>
+                      </a:endParaRPr>
+                    </a:p>
+                  </a:txBody>
+                  <a:tcPr marL="7087" marR="7087" marT="7087" marB="0" anchor="ctr"/>
+                </a:tc>
+                <a:tc>
+                  <a:txBody>
+                    <a:bodyPr/>
+                    <a:lstStyle/>
+                    <a:p>
+                      <a:pPr algn="l" fontAlgn="ctr">
+                        <a:buNone/>
+                      </a:pPr>
+                      <a:r>
+                        <a:rPr lang="en-US" sz="1100" u="none" strike="noStrike">
+                          <a:effectLst/>
+                        </a:rPr>
+                        <a:t>Topic Decision</a:t>
+                      </a:r>
+                      <a:endParaRPr lang="en-US" sz="1100" b="0" i="0" u="none" strike="noStrike">
+                        <a:solidFill>
+                          <a:srgbClr val="000000"/>
+                        </a:solidFill>
+                        <a:effectLst/>
+                        <a:latin typeface="Times New Roman" panose="02020603050405020304" pitchFamily="18" charset="0"/>
+                      </a:endParaRPr>
+                    </a:p>
+                  </a:txBody>
+                  <a:tcPr marL="63782" marR="7087" marT="7087" marB="0" anchor="ctr"/>
+                </a:tc>
+                <a:tc>
+                  <a:txBody>
+                    <a:bodyPr/>
+                    <a:lstStyle/>
+                    <a:p>
+                      <a:pPr algn="ctr" fontAlgn="ctr">
+                        <a:buNone/>
+                      </a:pPr>
+                      <a:r>
+                        <a:rPr lang="en-US" sz="1100" u="none" strike="noStrike">
+                          <a:effectLst/>
+                        </a:rPr>
+                        <a:t>27-Apr</a:t>
+                      </a:r>
+                      <a:endParaRPr lang="en-US" sz="1100" b="0" i="0" u="none" strike="noStrike">
+                        <a:solidFill>
+                          <a:srgbClr val="000000"/>
+                        </a:solidFill>
+                        <a:effectLst/>
+                        <a:latin typeface="Times New Roman" panose="02020603050405020304" pitchFamily="18" charset="0"/>
+                      </a:endParaRPr>
+                    </a:p>
+                  </a:txBody>
+                  <a:tcPr marL="7087" marR="7087" marT="7087" marB="0" anchor="ctr"/>
+                </a:tc>
+                <a:tc>
+                  <a:txBody>
+                    <a:bodyPr/>
+                    <a:lstStyle/>
+                    <a:p>
+                      <a:pPr algn="ctr" fontAlgn="ctr">
+                        <a:buNone/>
+                      </a:pPr>
+                      <a:r>
+                        <a:rPr lang="en-US" sz="1100" u="none" strike="noStrike">
+                          <a:effectLst/>
+                        </a:rPr>
+                        <a:t>27-Apr</a:t>
+                      </a:r>
+                      <a:endParaRPr lang="en-US" sz="1100" b="0" i="0" u="none" strike="noStrike">
+                        <a:solidFill>
+                          <a:srgbClr val="000000"/>
+                        </a:solidFill>
+                        <a:effectLst/>
+                        <a:latin typeface="Times New Roman" panose="02020603050405020304" pitchFamily="18" charset="0"/>
+                      </a:endParaRPr>
+                    </a:p>
+                  </a:txBody>
+                  <a:tcPr marL="7087" marR="7087" marT="7087" marB="0" anchor="ctr"/>
+                </a:tc>
+                <a:tc>
+                  <a:txBody>
+                    <a:bodyPr/>
+                    <a:lstStyle/>
+                    <a:p>
+                      <a:pPr algn="ctr" fontAlgn="ctr">
+                        <a:buNone/>
+                      </a:pPr>
+                      <a:r>
+                        <a:rPr lang="en-US" sz="1100" u="none" strike="noStrike">
+                          <a:effectLst/>
+                        </a:rPr>
+                        <a:t>1</a:t>
+                      </a:r>
+                      <a:endParaRPr lang="en-US" sz="1100" b="0" i="0" u="none" strike="noStrike">
+                        <a:solidFill>
+                          <a:srgbClr val="000000"/>
+                        </a:solidFill>
+                        <a:effectLst/>
+                        <a:latin typeface="Times New Roman" panose="02020603050405020304" pitchFamily="18" charset="0"/>
+                      </a:endParaRPr>
+                    </a:p>
+                  </a:txBody>
+                  <a:tcPr marL="7087" marR="7087" marT="7087" marB="0" anchor="ctr"/>
+                </a:tc>
+                <a:extLst>
+                  <a:ext uri="{0D108BD9-81ED-4DB2-BD59-A6C34878D82A}">
+                    <a16:rowId xmlns:a16="http://schemas.microsoft.com/office/drawing/2014/main" val="1308378324"/>
+                  </a:ext>
+                </a:extLst>
+              </a:tr>
+              <a:tr h="236442">
+                <a:tc>
+                  <a:txBody>
+                    <a:bodyPr/>
+                    <a:lstStyle/>
+                    <a:p>
+                      <a:pPr algn="ctr" fontAlgn="ctr">
+                        <a:buNone/>
+                      </a:pPr>
+                      <a:r>
+                        <a:rPr lang="en-US" sz="1100" u="none" strike="noStrike">
+                          <a:effectLst/>
+                        </a:rPr>
+                        <a:t>1.3</a:t>
+                      </a:r>
+                      <a:endParaRPr lang="en-US" sz="1100" b="0" i="0" u="none" strike="noStrike">
+                        <a:solidFill>
+                          <a:srgbClr val="000000"/>
+                        </a:solidFill>
+                        <a:effectLst/>
+                        <a:latin typeface="Times New Roman" panose="02020603050405020304" pitchFamily="18" charset="0"/>
+                      </a:endParaRPr>
+                    </a:p>
+                  </a:txBody>
+                  <a:tcPr marL="7087" marR="7087" marT="7087" marB="0" anchor="ctr"/>
+                </a:tc>
+                <a:tc>
+                  <a:txBody>
+                    <a:bodyPr/>
+                    <a:lstStyle/>
+                    <a:p>
+                      <a:pPr algn="l" fontAlgn="ctr">
+                        <a:buNone/>
+                      </a:pPr>
+                      <a:r>
+                        <a:rPr lang="en-US" sz="1100" u="none" strike="noStrike">
+                          <a:effectLst/>
+                        </a:rPr>
+                        <a:t>Presentation Preparation and Division</a:t>
+                      </a:r>
+                      <a:endParaRPr lang="en-US" sz="1100" b="0" i="0" u="none" strike="noStrike">
+                        <a:solidFill>
+                          <a:srgbClr val="000000"/>
+                        </a:solidFill>
+                        <a:effectLst/>
+                        <a:latin typeface="Times New Roman" panose="02020603050405020304" pitchFamily="18" charset="0"/>
+                      </a:endParaRPr>
+                    </a:p>
+                  </a:txBody>
+                  <a:tcPr marL="63782" marR="7087" marT="7087" marB="0" anchor="ctr"/>
+                </a:tc>
+                <a:tc>
+                  <a:txBody>
+                    <a:bodyPr/>
+                    <a:lstStyle/>
+                    <a:p>
+                      <a:pPr algn="ctr" fontAlgn="ctr">
+                        <a:buNone/>
+                      </a:pPr>
+                      <a:r>
+                        <a:rPr lang="en-US" sz="1100" u="none" strike="noStrike">
+                          <a:effectLst/>
+                        </a:rPr>
+                        <a:t>28-Apr</a:t>
+                      </a:r>
+                      <a:endParaRPr lang="en-US" sz="1100" b="0" i="0" u="none" strike="noStrike">
+                        <a:solidFill>
+                          <a:srgbClr val="000000"/>
+                        </a:solidFill>
+                        <a:effectLst/>
+                        <a:latin typeface="Times New Roman" panose="02020603050405020304" pitchFamily="18" charset="0"/>
+                      </a:endParaRPr>
+                    </a:p>
+                  </a:txBody>
+                  <a:tcPr marL="7087" marR="7087" marT="7087" marB="0" anchor="ctr"/>
+                </a:tc>
+                <a:tc>
+                  <a:txBody>
+                    <a:bodyPr/>
+                    <a:lstStyle/>
+                    <a:p>
+                      <a:pPr algn="ctr" fontAlgn="ctr">
+                        <a:buNone/>
+                      </a:pPr>
+                      <a:r>
+                        <a:rPr lang="en-US" sz="1100" u="none" strike="noStrike">
+                          <a:effectLst/>
+                        </a:rPr>
+                        <a:t>29-Apr</a:t>
+                      </a:r>
+                      <a:endParaRPr lang="en-US" sz="1100" b="0" i="0" u="none" strike="noStrike">
+                        <a:solidFill>
+                          <a:srgbClr val="000000"/>
+                        </a:solidFill>
+                        <a:effectLst/>
+                        <a:latin typeface="Times New Roman" panose="02020603050405020304" pitchFamily="18" charset="0"/>
+                      </a:endParaRPr>
+                    </a:p>
+                  </a:txBody>
+                  <a:tcPr marL="7087" marR="7087" marT="7087" marB="0" anchor="ctr"/>
+                </a:tc>
+                <a:tc>
+                  <a:txBody>
+                    <a:bodyPr/>
+                    <a:lstStyle/>
+                    <a:p>
+                      <a:pPr algn="ctr" fontAlgn="ctr">
+                        <a:buNone/>
+                      </a:pPr>
+                      <a:r>
+                        <a:rPr lang="en-US" sz="1100" u="none" strike="noStrike">
+                          <a:effectLst/>
+                        </a:rPr>
+                        <a:t>2</a:t>
+                      </a:r>
+                      <a:endParaRPr lang="en-US" sz="1100" b="0" i="0" u="none" strike="noStrike">
+                        <a:solidFill>
+                          <a:srgbClr val="000000"/>
+                        </a:solidFill>
+                        <a:effectLst/>
+                        <a:latin typeface="Times New Roman" panose="02020603050405020304" pitchFamily="18" charset="0"/>
+                      </a:endParaRPr>
+                    </a:p>
+                  </a:txBody>
+                  <a:tcPr marL="7087" marR="7087" marT="7087" marB="0" anchor="ctr"/>
+                </a:tc>
+                <a:extLst>
+                  <a:ext uri="{0D108BD9-81ED-4DB2-BD59-A6C34878D82A}">
+                    <a16:rowId xmlns:a16="http://schemas.microsoft.com/office/drawing/2014/main" val="2904173101"/>
+                  </a:ext>
+                </a:extLst>
+              </a:tr>
+              <a:tr h="236442">
+                <a:tc>
+                  <a:txBody>
+                    <a:bodyPr/>
+                    <a:lstStyle/>
+                    <a:p>
+                      <a:pPr algn="ctr" fontAlgn="ctr">
+                        <a:buNone/>
+                      </a:pPr>
+                      <a:r>
+                        <a:rPr lang="en-US" sz="1100" u="none" strike="noStrike">
+                          <a:effectLst/>
+                        </a:rPr>
+                        <a:t>2</a:t>
+                      </a:r>
+                      <a:endParaRPr lang="en-US" sz="1100" b="1" i="0" u="none" strike="noStrike">
+                        <a:solidFill>
+                          <a:srgbClr val="000000"/>
+                        </a:solidFill>
+                        <a:effectLst/>
+                        <a:latin typeface="Times New Roman" panose="02020603050405020304" pitchFamily="18" charset="0"/>
+                      </a:endParaRPr>
+                    </a:p>
+                  </a:txBody>
+                  <a:tcPr marL="7087" marR="7087" marT="7087" marB="0" anchor="ctr"/>
+                </a:tc>
+                <a:tc>
+                  <a:txBody>
+                    <a:bodyPr/>
+                    <a:lstStyle/>
+                    <a:p>
+                      <a:pPr algn="l" fontAlgn="ctr">
+                        <a:buNone/>
+                      </a:pPr>
+                      <a:r>
+                        <a:rPr lang="en-US" sz="1100" u="none" strike="noStrike" dirty="0">
+                          <a:effectLst/>
+                        </a:rPr>
+                        <a:t>Proposal Defense</a:t>
+                      </a:r>
+                      <a:endParaRPr lang="en-US" sz="1100" b="1" i="0" u="none" strike="noStrike" dirty="0">
+                        <a:solidFill>
+                          <a:srgbClr val="000000"/>
+                        </a:solidFill>
+                        <a:effectLst/>
+                        <a:latin typeface="Times New Roman" panose="02020603050405020304" pitchFamily="18" charset="0"/>
+                      </a:endParaRPr>
+                    </a:p>
+                  </a:txBody>
+                  <a:tcPr marL="63782" marR="7087" marT="7087" marB="0" anchor="ctr"/>
+                </a:tc>
+                <a:tc>
+                  <a:txBody>
+                    <a:bodyPr/>
+                    <a:lstStyle/>
+                    <a:p>
+                      <a:pPr algn="ctr" fontAlgn="ctr">
+                        <a:buNone/>
+                      </a:pPr>
+                      <a:r>
+                        <a:rPr lang="en-US" sz="1100" u="none" strike="noStrike">
+                          <a:effectLst/>
+                        </a:rPr>
+                        <a:t> </a:t>
+                      </a:r>
+                      <a:endParaRPr lang="en-US" sz="1100" b="0" i="0" u="none" strike="noStrike">
+                        <a:solidFill>
+                          <a:srgbClr val="000000"/>
+                        </a:solidFill>
+                        <a:effectLst/>
+                        <a:latin typeface="Times New Roman" panose="02020603050405020304" pitchFamily="18" charset="0"/>
+                      </a:endParaRPr>
+                    </a:p>
+                  </a:txBody>
+                  <a:tcPr marL="7087" marR="7087" marT="7087" marB="0" anchor="ctr"/>
+                </a:tc>
+                <a:tc>
+                  <a:txBody>
+                    <a:bodyPr/>
+                    <a:lstStyle/>
+                    <a:p>
+                      <a:pPr algn="ctr" fontAlgn="ctr">
+                        <a:buNone/>
+                      </a:pPr>
+                      <a:r>
+                        <a:rPr lang="en-US" sz="1100" u="none" strike="noStrike">
+                          <a:effectLst/>
+                        </a:rPr>
+                        <a:t> </a:t>
+                      </a:r>
+                      <a:endParaRPr lang="en-US" sz="1100" b="0" i="0" u="none" strike="noStrike">
+                        <a:solidFill>
+                          <a:srgbClr val="000000"/>
+                        </a:solidFill>
+                        <a:effectLst/>
+                        <a:latin typeface="Times New Roman" panose="02020603050405020304" pitchFamily="18" charset="0"/>
+                      </a:endParaRPr>
+                    </a:p>
+                  </a:txBody>
+                  <a:tcPr marL="7087" marR="7087" marT="7087" marB="0" anchor="ctr"/>
+                </a:tc>
+                <a:tc>
+                  <a:txBody>
+                    <a:bodyPr/>
+                    <a:lstStyle/>
+                    <a:p>
+                      <a:pPr algn="ctr" fontAlgn="ctr">
+                        <a:buNone/>
+                      </a:pPr>
+                      <a:r>
+                        <a:rPr lang="en-US" sz="1100" u="none" strike="noStrike">
+                          <a:effectLst/>
+                        </a:rPr>
+                        <a:t> </a:t>
+                      </a:r>
+                      <a:endParaRPr lang="en-US" sz="1100" b="0" i="0" u="none" strike="noStrike">
+                        <a:solidFill>
+                          <a:srgbClr val="000000"/>
+                        </a:solidFill>
+                        <a:effectLst/>
+                        <a:latin typeface="Times New Roman" panose="02020603050405020304" pitchFamily="18" charset="0"/>
+                      </a:endParaRPr>
+                    </a:p>
+                  </a:txBody>
+                  <a:tcPr marL="7087" marR="7087" marT="7087" marB="0" anchor="ctr"/>
+                </a:tc>
+                <a:extLst>
+                  <a:ext uri="{0D108BD9-81ED-4DB2-BD59-A6C34878D82A}">
+                    <a16:rowId xmlns:a16="http://schemas.microsoft.com/office/drawing/2014/main" val="2845215221"/>
+                  </a:ext>
+                </a:extLst>
+              </a:tr>
+              <a:tr h="236442">
+                <a:tc>
+                  <a:txBody>
+                    <a:bodyPr/>
+                    <a:lstStyle/>
+                    <a:p>
+                      <a:pPr algn="ctr" fontAlgn="ctr">
+                        <a:buNone/>
+                      </a:pPr>
+                      <a:r>
+                        <a:rPr lang="en-US" sz="1100" u="none" strike="noStrike">
+                          <a:effectLst/>
+                        </a:rPr>
+                        <a:t>2.1</a:t>
+                      </a:r>
+                      <a:endParaRPr lang="en-US" sz="1100" b="0" i="0" u="none" strike="noStrike">
+                        <a:solidFill>
+                          <a:srgbClr val="000000"/>
+                        </a:solidFill>
+                        <a:effectLst/>
+                        <a:latin typeface="Times New Roman" panose="02020603050405020304" pitchFamily="18" charset="0"/>
+                      </a:endParaRPr>
+                    </a:p>
+                  </a:txBody>
+                  <a:tcPr marL="7087" marR="7087" marT="7087" marB="0" anchor="ctr"/>
+                </a:tc>
+                <a:tc>
+                  <a:txBody>
+                    <a:bodyPr/>
+                    <a:lstStyle/>
+                    <a:p>
+                      <a:pPr algn="l" fontAlgn="ctr">
+                        <a:buNone/>
+                      </a:pPr>
+                      <a:r>
+                        <a:rPr lang="en-US" sz="1100" u="none" strike="noStrike">
+                          <a:effectLst/>
+                        </a:rPr>
+                        <a:t>Literature Review and Figma Designing</a:t>
+                      </a:r>
+                      <a:endParaRPr lang="en-US" sz="1100" b="0" i="0" u="none" strike="noStrike">
+                        <a:solidFill>
+                          <a:srgbClr val="000000"/>
+                        </a:solidFill>
+                        <a:effectLst/>
+                        <a:latin typeface="Times New Roman" panose="02020603050405020304" pitchFamily="18" charset="0"/>
+                      </a:endParaRPr>
+                    </a:p>
+                  </a:txBody>
+                  <a:tcPr marL="63782" marR="7087" marT="7087" marB="0" anchor="ctr"/>
+                </a:tc>
+                <a:tc>
+                  <a:txBody>
+                    <a:bodyPr/>
+                    <a:lstStyle/>
+                    <a:p>
+                      <a:pPr algn="ctr" fontAlgn="ctr">
+                        <a:buNone/>
+                      </a:pPr>
+                      <a:r>
+                        <a:rPr lang="en-US" sz="1100" u="none" strike="noStrike">
+                          <a:effectLst/>
+                        </a:rPr>
+                        <a:t>30-Apr</a:t>
+                      </a:r>
+                      <a:endParaRPr lang="en-US" sz="1100" b="0" i="0" u="none" strike="noStrike">
+                        <a:solidFill>
+                          <a:srgbClr val="000000"/>
+                        </a:solidFill>
+                        <a:effectLst/>
+                        <a:latin typeface="Times New Roman" panose="02020603050405020304" pitchFamily="18" charset="0"/>
+                      </a:endParaRPr>
+                    </a:p>
+                  </a:txBody>
+                  <a:tcPr marL="7087" marR="7087" marT="7087" marB="0" anchor="ctr"/>
+                </a:tc>
+                <a:tc>
+                  <a:txBody>
+                    <a:bodyPr/>
+                    <a:lstStyle/>
+                    <a:p>
+                      <a:pPr algn="ctr" fontAlgn="ctr">
+                        <a:buNone/>
+                      </a:pPr>
+                      <a:r>
+                        <a:rPr lang="en-US" sz="1100" u="none" strike="noStrike">
+                          <a:effectLst/>
+                        </a:rPr>
+                        <a:t>02-May</a:t>
+                      </a:r>
+                      <a:endParaRPr lang="en-US" sz="1100" b="0" i="0" u="none" strike="noStrike">
+                        <a:solidFill>
+                          <a:srgbClr val="000000"/>
+                        </a:solidFill>
+                        <a:effectLst/>
+                        <a:latin typeface="Times New Roman" panose="02020603050405020304" pitchFamily="18" charset="0"/>
+                      </a:endParaRPr>
+                    </a:p>
+                  </a:txBody>
+                  <a:tcPr marL="7087" marR="7087" marT="7087" marB="0" anchor="ctr"/>
+                </a:tc>
+                <a:tc>
+                  <a:txBody>
+                    <a:bodyPr/>
+                    <a:lstStyle/>
+                    <a:p>
+                      <a:pPr algn="ctr" fontAlgn="ctr">
+                        <a:buNone/>
+                      </a:pPr>
+                      <a:r>
+                        <a:rPr lang="en-US" sz="1100" u="none" strike="noStrike">
+                          <a:effectLst/>
+                        </a:rPr>
+                        <a:t>3</a:t>
+                      </a:r>
+                      <a:endParaRPr lang="en-US" sz="1100" b="0" i="0" u="none" strike="noStrike">
+                        <a:solidFill>
+                          <a:srgbClr val="000000"/>
+                        </a:solidFill>
+                        <a:effectLst/>
+                        <a:latin typeface="Times New Roman" panose="02020603050405020304" pitchFamily="18" charset="0"/>
+                      </a:endParaRPr>
+                    </a:p>
+                  </a:txBody>
+                  <a:tcPr marL="7087" marR="7087" marT="7087" marB="0" anchor="ctr"/>
+                </a:tc>
+                <a:extLst>
+                  <a:ext uri="{0D108BD9-81ED-4DB2-BD59-A6C34878D82A}">
+                    <a16:rowId xmlns:a16="http://schemas.microsoft.com/office/drawing/2014/main" val="1984674709"/>
+                  </a:ext>
+                </a:extLst>
+              </a:tr>
+              <a:tr h="236442">
+                <a:tc>
+                  <a:txBody>
+                    <a:bodyPr/>
+                    <a:lstStyle/>
+                    <a:p>
+                      <a:pPr algn="ctr" fontAlgn="ctr">
+                        <a:buNone/>
+                      </a:pPr>
+                      <a:r>
+                        <a:rPr lang="en-US" sz="1100" u="none" strike="noStrike">
+                          <a:effectLst/>
+                        </a:rPr>
+                        <a:t>2.2</a:t>
+                      </a:r>
+                      <a:endParaRPr lang="en-US" sz="1100" b="0" i="0" u="none" strike="noStrike">
+                        <a:solidFill>
+                          <a:srgbClr val="000000"/>
+                        </a:solidFill>
+                        <a:effectLst/>
+                        <a:latin typeface="Times New Roman" panose="02020603050405020304" pitchFamily="18" charset="0"/>
+                      </a:endParaRPr>
+                    </a:p>
+                  </a:txBody>
+                  <a:tcPr marL="7087" marR="7087" marT="7087" marB="0" anchor="ctr"/>
+                </a:tc>
+                <a:tc>
+                  <a:txBody>
+                    <a:bodyPr/>
+                    <a:lstStyle/>
+                    <a:p>
+                      <a:pPr algn="l" fontAlgn="ctr">
+                        <a:buNone/>
+                      </a:pPr>
+                      <a:r>
+                        <a:rPr lang="en-US" sz="1100" u="none" strike="noStrike">
+                          <a:effectLst/>
+                        </a:rPr>
+                        <a:t>UML Diagrams</a:t>
+                      </a:r>
+                      <a:endParaRPr lang="en-US" sz="1100" b="0" i="0" u="none" strike="noStrike">
+                        <a:solidFill>
+                          <a:srgbClr val="000000"/>
+                        </a:solidFill>
+                        <a:effectLst/>
+                        <a:latin typeface="Times New Roman" panose="02020603050405020304" pitchFamily="18" charset="0"/>
+                      </a:endParaRPr>
+                    </a:p>
+                  </a:txBody>
+                  <a:tcPr marL="63782" marR="7087" marT="7087" marB="0" anchor="ctr"/>
+                </a:tc>
+                <a:tc>
+                  <a:txBody>
+                    <a:bodyPr/>
+                    <a:lstStyle/>
+                    <a:p>
+                      <a:pPr algn="ctr" fontAlgn="ctr">
+                        <a:buNone/>
+                      </a:pPr>
+                      <a:r>
+                        <a:rPr lang="en-US" sz="1100" u="none" strike="noStrike">
+                          <a:effectLst/>
+                        </a:rPr>
+                        <a:t>03-May</a:t>
+                      </a:r>
+                      <a:endParaRPr lang="en-US" sz="1100" b="0" i="0" u="none" strike="noStrike">
+                        <a:solidFill>
+                          <a:srgbClr val="000000"/>
+                        </a:solidFill>
+                        <a:effectLst/>
+                        <a:latin typeface="Times New Roman" panose="02020603050405020304" pitchFamily="18" charset="0"/>
+                      </a:endParaRPr>
+                    </a:p>
+                  </a:txBody>
+                  <a:tcPr marL="7087" marR="7087" marT="7087" marB="0" anchor="ctr"/>
+                </a:tc>
+                <a:tc>
+                  <a:txBody>
+                    <a:bodyPr/>
+                    <a:lstStyle/>
+                    <a:p>
+                      <a:pPr algn="ctr" fontAlgn="ctr">
+                        <a:buNone/>
+                      </a:pPr>
+                      <a:r>
+                        <a:rPr lang="en-US" sz="1100" u="none" strike="noStrike">
+                          <a:effectLst/>
+                        </a:rPr>
+                        <a:t>06-May</a:t>
+                      </a:r>
+                      <a:endParaRPr lang="en-US" sz="1100" b="0" i="0" u="none" strike="noStrike">
+                        <a:solidFill>
+                          <a:srgbClr val="000000"/>
+                        </a:solidFill>
+                        <a:effectLst/>
+                        <a:latin typeface="Times New Roman" panose="02020603050405020304" pitchFamily="18" charset="0"/>
+                      </a:endParaRPr>
+                    </a:p>
+                  </a:txBody>
+                  <a:tcPr marL="7087" marR="7087" marT="7087" marB="0" anchor="ctr"/>
+                </a:tc>
+                <a:tc>
+                  <a:txBody>
+                    <a:bodyPr/>
+                    <a:lstStyle/>
+                    <a:p>
+                      <a:pPr algn="ctr" fontAlgn="ctr">
+                        <a:buNone/>
+                      </a:pPr>
+                      <a:r>
+                        <a:rPr lang="en-US" sz="1100" u="none" strike="noStrike">
+                          <a:effectLst/>
+                        </a:rPr>
+                        <a:t>4</a:t>
+                      </a:r>
+                      <a:endParaRPr lang="en-US" sz="1100" b="0" i="0" u="none" strike="noStrike">
+                        <a:solidFill>
+                          <a:srgbClr val="000000"/>
+                        </a:solidFill>
+                        <a:effectLst/>
+                        <a:latin typeface="Times New Roman" panose="02020603050405020304" pitchFamily="18" charset="0"/>
+                      </a:endParaRPr>
+                    </a:p>
+                  </a:txBody>
+                  <a:tcPr marL="7087" marR="7087" marT="7087" marB="0" anchor="ctr"/>
+                </a:tc>
+                <a:extLst>
+                  <a:ext uri="{0D108BD9-81ED-4DB2-BD59-A6C34878D82A}">
+                    <a16:rowId xmlns:a16="http://schemas.microsoft.com/office/drawing/2014/main" val="2208198754"/>
+                  </a:ext>
+                </a:extLst>
+              </a:tr>
+              <a:tr h="236442">
+                <a:tc>
+                  <a:txBody>
+                    <a:bodyPr/>
+                    <a:lstStyle/>
+                    <a:p>
+                      <a:pPr algn="ctr" fontAlgn="ctr">
+                        <a:buNone/>
+                      </a:pPr>
+                      <a:r>
+                        <a:rPr lang="en-US" sz="1100" u="none" strike="noStrike">
+                          <a:effectLst/>
+                        </a:rPr>
+                        <a:t>2.3</a:t>
+                      </a:r>
+                      <a:endParaRPr lang="en-US" sz="1100" b="0" i="0" u="none" strike="noStrike">
+                        <a:solidFill>
+                          <a:srgbClr val="000000"/>
+                        </a:solidFill>
+                        <a:effectLst/>
+                        <a:latin typeface="Times New Roman" panose="02020603050405020304" pitchFamily="18" charset="0"/>
+                      </a:endParaRPr>
+                    </a:p>
+                  </a:txBody>
+                  <a:tcPr marL="7087" marR="7087" marT="7087" marB="0" anchor="ctr"/>
+                </a:tc>
+                <a:tc>
+                  <a:txBody>
+                    <a:bodyPr/>
+                    <a:lstStyle/>
+                    <a:p>
+                      <a:pPr algn="l" fontAlgn="ctr">
+                        <a:buNone/>
+                      </a:pPr>
+                      <a:r>
+                        <a:rPr lang="en-US" sz="1100" u="none" strike="noStrike">
+                          <a:effectLst/>
+                        </a:rPr>
+                        <a:t>Backlog</a:t>
+                      </a:r>
+                      <a:endParaRPr lang="en-US" sz="1100" b="0" i="0" u="none" strike="noStrike">
+                        <a:solidFill>
+                          <a:srgbClr val="000000"/>
+                        </a:solidFill>
+                        <a:effectLst/>
+                        <a:latin typeface="Times New Roman" panose="02020603050405020304" pitchFamily="18" charset="0"/>
+                      </a:endParaRPr>
+                    </a:p>
+                  </a:txBody>
+                  <a:tcPr marL="63782" marR="7087" marT="7087" marB="0" anchor="ctr"/>
+                </a:tc>
+                <a:tc>
+                  <a:txBody>
+                    <a:bodyPr/>
+                    <a:lstStyle/>
+                    <a:p>
+                      <a:pPr algn="ctr" fontAlgn="ctr">
+                        <a:buNone/>
+                      </a:pPr>
+                      <a:r>
+                        <a:rPr lang="en-US" sz="1100" u="none" strike="noStrike">
+                          <a:effectLst/>
+                        </a:rPr>
+                        <a:t>07-May</a:t>
+                      </a:r>
+                      <a:endParaRPr lang="en-US" sz="1100" b="0" i="0" u="none" strike="noStrike">
+                        <a:solidFill>
+                          <a:srgbClr val="000000"/>
+                        </a:solidFill>
+                        <a:effectLst/>
+                        <a:latin typeface="Times New Roman" panose="02020603050405020304" pitchFamily="18" charset="0"/>
+                      </a:endParaRPr>
+                    </a:p>
+                  </a:txBody>
+                  <a:tcPr marL="7087" marR="7087" marT="7087" marB="0" anchor="ctr"/>
+                </a:tc>
+                <a:tc>
+                  <a:txBody>
+                    <a:bodyPr/>
+                    <a:lstStyle/>
+                    <a:p>
+                      <a:pPr algn="ctr" fontAlgn="ctr">
+                        <a:buNone/>
+                      </a:pPr>
+                      <a:r>
+                        <a:rPr lang="en-US" sz="1100" u="none" strike="noStrike">
+                          <a:effectLst/>
+                        </a:rPr>
+                        <a:t>07-May</a:t>
+                      </a:r>
+                      <a:endParaRPr lang="en-US" sz="1100" b="0" i="0" u="none" strike="noStrike">
+                        <a:solidFill>
+                          <a:srgbClr val="000000"/>
+                        </a:solidFill>
+                        <a:effectLst/>
+                        <a:latin typeface="Times New Roman" panose="02020603050405020304" pitchFamily="18" charset="0"/>
+                      </a:endParaRPr>
+                    </a:p>
+                  </a:txBody>
+                  <a:tcPr marL="7087" marR="7087" marT="7087" marB="0" anchor="ctr"/>
+                </a:tc>
+                <a:tc>
+                  <a:txBody>
+                    <a:bodyPr/>
+                    <a:lstStyle/>
+                    <a:p>
+                      <a:pPr algn="ctr" fontAlgn="ctr">
+                        <a:buNone/>
+                      </a:pPr>
+                      <a:r>
+                        <a:rPr lang="en-US" sz="1100" u="none" strike="noStrike">
+                          <a:effectLst/>
+                        </a:rPr>
+                        <a:t>1</a:t>
+                      </a:r>
+                      <a:endParaRPr lang="en-US" sz="1100" b="0" i="0" u="none" strike="noStrike">
+                        <a:solidFill>
+                          <a:srgbClr val="000000"/>
+                        </a:solidFill>
+                        <a:effectLst/>
+                        <a:latin typeface="Times New Roman" panose="02020603050405020304" pitchFamily="18" charset="0"/>
+                      </a:endParaRPr>
+                    </a:p>
+                  </a:txBody>
+                  <a:tcPr marL="7087" marR="7087" marT="7087" marB="0" anchor="ctr"/>
+                </a:tc>
+                <a:extLst>
+                  <a:ext uri="{0D108BD9-81ED-4DB2-BD59-A6C34878D82A}">
+                    <a16:rowId xmlns:a16="http://schemas.microsoft.com/office/drawing/2014/main" val="3303921938"/>
+                  </a:ext>
+                </a:extLst>
+              </a:tr>
+              <a:tr h="227349">
+                <a:tc>
+                  <a:txBody>
+                    <a:bodyPr/>
+                    <a:lstStyle/>
+                    <a:p>
+                      <a:pPr algn="ctr" fontAlgn="ctr">
+                        <a:buNone/>
+                      </a:pPr>
+                      <a:r>
+                        <a:rPr lang="en-US" sz="1100" u="none" strike="noStrike">
+                          <a:effectLst/>
+                        </a:rPr>
+                        <a:t>2.4</a:t>
+                      </a:r>
+                      <a:endParaRPr lang="en-US" sz="1100" b="0" i="0" u="none" strike="noStrike">
+                        <a:solidFill>
+                          <a:srgbClr val="000000"/>
+                        </a:solidFill>
+                        <a:effectLst/>
+                        <a:latin typeface="Times New Roman" panose="02020603050405020304" pitchFamily="18" charset="0"/>
+                      </a:endParaRPr>
+                    </a:p>
+                  </a:txBody>
+                  <a:tcPr marL="7087" marR="7087" marT="7087" marB="0" anchor="ctr"/>
+                </a:tc>
+                <a:tc>
+                  <a:txBody>
+                    <a:bodyPr/>
+                    <a:lstStyle/>
+                    <a:p>
+                      <a:pPr algn="l" fontAlgn="ctr">
+                        <a:buNone/>
+                      </a:pPr>
+                      <a:r>
+                        <a:rPr lang="en-US" sz="1100" u="none" strike="noStrike">
+                          <a:effectLst/>
+                        </a:rPr>
+                        <a:t>Preparation of Documentation and Presentation</a:t>
+                      </a:r>
+                      <a:endParaRPr lang="en-US" sz="1100" b="0" i="0" u="none" strike="noStrike">
+                        <a:solidFill>
+                          <a:srgbClr val="000000"/>
+                        </a:solidFill>
+                        <a:effectLst/>
+                        <a:latin typeface="Times New Roman" panose="02020603050405020304" pitchFamily="18" charset="0"/>
+                      </a:endParaRPr>
+                    </a:p>
+                  </a:txBody>
+                  <a:tcPr marL="63782" marR="7087" marT="7087" marB="0" anchor="ctr"/>
+                </a:tc>
+                <a:tc>
+                  <a:txBody>
+                    <a:bodyPr/>
+                    <a:lstStyle/>
+                    <a:p>
+                      <a:pPr algn="ctr" fontAlgn="ctr">
+                        <a:buNone/>
+                      </a:pPr>
+                      <a:r>
+                        <a:rPr lang="en-US" sz="1100" u="none" strike="noStrike">
+                          <a:effectLst/>
+                        </a:rPr>
+                        <a:t>08-May</a:t>
+                      </a:r>
+                      <a:endParaRPr lang="en-US" sz="1100" b="0" i="0" u="none" strike="noStrike">
+                        <a:solidFill>
+                          <a:srgbClr val="000000"/>
+                        </a:solidFill>
+                        <a:effectLst/>
+                        <a:latin typeface="Times New Roman" panose="02020603050405020304" pitchFamily="18" charset="0"/>
+                      </a:endParaRPr>
+                    </a:p>
+                  </a:txBody>
+                  <a:tcPr marL="7087" marR="7087" marT="7087" marB="0" anchor="ctr"/>
+                </a:tc>
+                <a:tc>
+                  <a:txBody>
+                    <a:bodyPr/>
+                    <a:lstStyle/>
+                    <a:p>
+                      <a:pPr algn="ctr" fontAlgn="ctr">
+                        <a:buNone/>
+                      </a:pPr>
+                      <a:r>
+                        <a:rPr lang="en-US" sz="1100" u="none" strike="noStrike">
+                          <a:effectLst/>
+                        </a:rPr>
+                        <a:t>09-May</a:t>
+                      </a:r>
+                      <a:endParaRPr lang="en-US" sz="1100" b="0" i="0" u="none" strike="noStrike">
+                        <a:solidFill>
+                          <a:srgbClr val="000000"/>
+                        </a:solidFill>
+                        <a:effectLst/>
+                        <a:latin typeface="Times New Roman" panose="02020603050405020304" pitchFamily="18" charset="0"/>
+                      </a:endParaRPr>
+                    </a:p>
+                  </a:txBody>
+                  <a:tcPr marL="7087" marR="7087" marT="7087" marB="0" anchor="ctr"/>
+                </a:tc>
+                <a:tc>
+                  <a:txBody>
+                    <a:bodyPr/>
+                    <a:lstStyle/>
+                    <a:p>
+                      <a:pPr algn="ctr" fontAlgn="ctr">
+                        <a:buNone/>
+                      </a:pPr>
+                      <a:r>
+                        <a:rPr lang="en-US" sz="1100" u="none" strike="noStrike">
+                          <a:effectLst/>
+                        </a:rPr>
+                        <a:t>2</a:t>
+                      </a:r>
+                      <a:endParaRPr lang="en-US" sz="1100" b="0" i="0" u="none" strike="noStrike">
+                        <a:solidFill>
+                          <a:srgbClr val="000000"/>
+                        </a:solidFill>
+                        <a:effectLst/>
+                        <a:latin typeface="Times New Roman" panose="02020603050405020304" pitchFamily="18" charset="0"/>
+                      </a:endParaRPr>
+                    </a:p>
+                  </a:txBody>
+                  <a:tcPr marL="7087" marR="7087" marT="7087" marB="0" anchor="ctr"/>
+                </a:tc>
+                <a:extLst>
+                  <a:ext uri="{0D108BD9-81ED-4DB2-BD59-A6C34878D82A}">
+                    <a16:rowId xmlns:a16="http://schemas.microsoft.com/office/drawing/2014/main" val="4018946370"/>
+                  </a:ext>
+                </a:extLst>
+              </a:tr>
+              <a:tr h="236442">
+                <a:tc>
+                  <a:txBody>
+                    <a:bodyPr/>
+                    <a:lstStyle/>
+                    <a:p>
+                      <a:pPr algn="ctr" fontAlgn="ctr">
+                        <a:buNone/>
+                      </a:pPr>
+                      <a:r>
+                        <a:rPr lang="en-US" sz="1100" u="none" strike="noStrike">
+                          <a:effectLst/>
+                        </a:rPr>
+                        <a:t>3</a:t>
+                      </a:r>
+                      <a:endParaRPr lang="en-US" sz="1100" b="1" i="0" u="none" strike="noStrike">
+                        <a:solidFill>
+                          <a:srgbClr val="000000"/>
+                        </a:solidFill>
+                        <a:effectLst/>
+                        <a:latin typeface="Times New Roman" panose="02020603050405020304" pitchFamily="18" charset="0"/>
+                      </a:endParaRPr>
+                    </a:p>
+                  </a:txBody>
+                  <a:tcPr marL="7087" marR="7087" marT="7087" marB="0" anchor="ctr"/>
+                </a:tc>
+                <a:tc>
+                  <a:txBody>
+                    <a:bodyPr/>
+                    <a:lstStyle/>
+                    <a:p>
+                      <a:pPr algn="l" fontAlgn="ctr">
+                        <a:buNone/>
+                      </a:pPr>
+                      <a:r>
+                        <a:rPr lang="en-US" sz="1100" u="none" strike="noStrike">
+                          <a:effectLst/>
+                        </a:rPr>
+                        <a:t>Mid-Term Defense</a:t>
+                      </a:r>
+                      <a:endParaRPr lang="en-US" sz="1100" b="1" i="0" u="none" strike="noStrike">
+                        <a:solidFill>
+                          <a:srgbClr val="000000"/>
+                        </a:solidFill>
+                        <a:effectLst/>
+                        <a:latin typeface="Times New Roman" panose="02020603050405020304" pitchFamily="18" charset="0"/>
+                      </a:endParaRPr>
+                    </a:p>
+                  </a:txBody>
+                  <a:tcPr marL="63782" marR="7087" marT="7087" marB="0" anchor="ctr"/>
+                </a:tc>
+                <a:tc>
+                  <a:txBody>
+                    <a:bodyPr/>
+                    <a:lstStyle/>
+                    <a:p>
+                      <a:pPr algn="ctr" fontAlgn="ctr">
+                        <a:buNone/>
+                      </a:pPr>
+                      <a:r>
+                        <a:rPr lang="en-US" sz="1100" u="none" strike="noStrike">
+                          <a:effectLst/>
+                        </a:rPr>
+                        <a:t> </a:t>
+                      </a:r>
+                      <a:endParaRPr lang="en-US" sz="1100" b="0" i="0" u="none" strike="noStrike">
+                        <a:solidFill>
+                          <a:srgbClr val="000000"/>
+                        </a:solidFill>
+                        <a:effectLst/>
+                        <a:latin typeface="Times New Roman" panose="02020603050405020304" pitchFamily="18" charset="0"/>
+                      </a:endParaRPr>
+                    </a:p>
+                  </a:txBody>
+                  <a:tcPr marL="7087" marR="7087" marT="7087" marB="0" anchor="ctr"/>
+                </a:tc>
+                <a:tc>
+                  <a:txBody>
+                    <a:bodyPr/>
+                    <a:lstStyle/>
+                    <a:p>
+                      <a:pPr algn="ctr" fontAlgn="ctr">
+                        <a:buNone/>
+                      </a:pPr>
+                      <a:r>
+                        <a:rPr lang="en-US" sz="1100" u="none" strike="noStrike">
+                          <a:effectLst/>
+                        </a:rPr>
+                        <a:t> </a:t>
+                      </a:r>
+                      <a:endParaRPr lang="en-US" sz="1100" b="0" i="0" u="none" strike="noStrike">
+                        <a:solidFill>
+                          <a:srgbClr val="000000"/>
+                        </a:solidFill>
+                        <a:effectLst/>
+                        <a:latin typeface="Times New Roman" panose="02020603050405020304" pitchFamily="18" charset="0"/>
+                      </a:endParaRPr>
+                    </a:p>
+                  </a:txBody>
+                  <a:tcPr marL="7087" marR="7087" marT="7087" marB="0" anchor="ctr"/>
+                </a:tc>
+                <a:tc>
+                  <a:txBody>
+                    <a:bodyPr/>
+                    <a:lstStyle/>
+                    <a:p>
+                      <a:pPr algn="ctr" fontAlgn="ctr">
+                        <a:buNone/>
+                      </a:pPr>
+                      <a:r>
+                        <a:rPr lang="en-US" sz="1100" u="none" strike="noStrike">
+                          <a:effectLst/>
+                        </a:rPr>
+                        <a:t> </a:t>
+                      </a:r>
+                      <a:endParaRPr lang="en-US" sz="1100" b="0" i="0" u="none" strike="noStrike">
+                        <a:solidFill>
+                          <a:srgbClr val="000000"/>
+                        </a:solidFill>
+                        <a:effectLst/>
+                        <a:latin typeface="Times New Roman" panose="02020603050405020304" pitchFamily="18" charset="0"/>
+                      </a:endParaRPr>
+                    </a:p>
+                  </a:txBody>
+                  <a:tcPr marL="7087" marR="7087" marT="7087" marB="0" anchor="ctr"/>
+                </a:tc>
+                <a:extLst>
+                  <a:ext uri="{0D108BD9-81ED-4DB2-BD59-A6C34878D82A}">
+                    <a16:rowId xmlns:a16="http://schemas.microsoft.com/office/drawing/2014/main" val="1920786974"/>
+                  </a:ext>
+                </a:extLst>
+              </a:tr>
+              <a:tr h="236442">
+                <a:tc>
+                  <a:txBody>
+                    <a:bodyPr/>
+                    <a:lstStyle/>
+                    <a:p>
+                      <a:pPr algn="ctr" fontAlgn="ctr">
+                        <a:buNone/>
+                      </a:pPr>
+                      <a:r>
+                        <a:rPr lang="en-US" sz="1100" u="none" strike="noStrike">
+                          <a:effectLst/>
+                        </a:rPr>
+                        <a:t>3.1</a:t>
+                      </a:r>
+                      <a:endParaRPr lang="en-US" sz="1100" b="0" i="0" u="none" strike="noStrike">
+                        <a:solidFill>
+                          <a:srgbClr val="000000"/>
+                        </a:solidFill>
+                        <a:effectLst/>
+                        <a:latin typeface="Times New Roman" panose="02020603050405020304" pitchFamily="18" charset="0"/>
+                      </a:endParaRPr>
+                    </a:p>
+                  </a:txBody>
+                  <a:tcPr marL="7087" marR="7087" marT="7087" marB="0" anchor="ctr"/>
+                </a:tc>
+                <a:tc>
+                  <a:txBody>
+                    <a:bodyPr/>
+                    <a:lstStyle/>
+                    <a:p>
+                      <a:pPr algn="l" fontAlgn="ctr">
+                        <a:buNone/>
+                      </a:pPr>
+                      <a:r>
+                        <a:rPr lang="en-US" sz="1100" u="none" strike="noStrike">
+                          <a:effectLst/>
+                        </a:rPr>
+                        <a:t>Correction of Diagrams and Project Work Division</a:t>
+                      </a:r>
+                      <a:endParaRPr lang="en-US" sz="1100" b="0" i="0" u="none" strike="noStrike">
+                        <a:solidFill>
+                          <a:srgbClr val="000000"/>
+                        </a:solidFill>
+                        <a:effectLst/>
+                        <a:latin typeface="Times New Roman" panose="02020603050405020304" pitchFamily="18" charset="0"/>
+                      </a:endParaRPr>
+                    </a:p>
+                  </a:txBody>
+                  <a:tcPr marL="63782" marR="7087" marT="7087" marB="0" anchor="ctr"/>
+                </a:tc>
+                <a:tc>
+                  <a:txBody>
+                    <a:bodyPr/>
+                    <a:lstStyle/>
+                    <a:p>
+                      <a:pPr algn="ctr" fontAlgn="ctr">
+                        <a:buNone/>
+                      </a:pPr>
+                      <a:r>
+                        <a:rPr lang="en-US" sz="1100" u="none" strike="noStrike">
+                          <a:effectLst/>
+                        </a:rPr>
+                        <a:t>14-May</a:t>
+                      </a:r>
+                      <a:endParaRPr lang="en-US" sz="1100" b="0" i="0" u="none" strike="noStrike">
+                        <a:solidFill>
+                          <a:srgbClr val="000000"/>
+                        </a:solidFill>
+                        <a:effectLst/>
+                        <a:latin typeface="Times New Roman" panose="02020603050405020304" pitchFamily="18" charset="0"/>
+                      </a:endParaRPr>
+                    </a:p>
+                  </a:txBody>
+                  <a:tcPr marL="7087" marR="7087" marT="7087" marB="0" anchor="ctr"/>
+                </a:tc>
+                <a:tc>
+                  <a:txBody>
+                    <a:bodyPr/>
+                    <a:lstStyle/>
+                    <a:p>
+                      <a:pPr algn="ctr" fontAlgn="ctr">
+                        <a:buNone/>
+                      </a:pPr>
+                      <a:r>
+                        <a:rPr lang="en-US" sz="1100" u="none" strike="noStrike">
+                          <a:effectLst/>
+                        </a:rPr>
+                        <a:t>15-May</a:t>
+                      </a:r>
+                      <a:endParaRPr lang="en-US" sz="1100" b="0" i="0" u="none" strike="noStrike">
+                        <a:solidFill>
+                          <a:srgbClr val="000000"/>
+                        </a:solidFill>
+                        <a:effectLst/>
+                        <a:latin typeface="Times New Roman" panose="02020603050405020304" pitchFamily="18" charset="0"/>
+                      </a:endParaRPr>
+                    </a:p>
+                  </a:txBody>
+                  <a:tcPr marL="7087" marR="7087" marT="7087" marB="0" anchor="ctr"/>
+                </a:tc>
+                <a:tc>
+                  <a:txBody>
+                    <a:bodyPr/>
+                    <a:lstStyle/>
+                    <a:p>
+                      <a:pPr algn="ctr" fontAlgn="ctr">
+                        <a:buNone/>
+                      </a:pPr>
+                      <a:r>
+                        <a:rPr lang="en-US" sz="1100" u="none" strike="noStrike">
+                          <a:effectLst/>
+                        </a:rPr>
+                        <a:t>2</a:t>
+                      </a:r>
+                      <a:endParaRPr lang="en-US" sz="1100" b="0" i="0" u="none" strike="noStrike">
+                        <a:solidFill>
+                          <a:srgbClr val="000000"/>
+                        </a:solidFill>
+                        <a:effectLst/>
+                        <a:latin typeface="Times New Roman" panose="02020603050405020304" pitchFamily="18" charset="0"/>
+                      </a:endParaRPr>
+                    </a:p>
+                  </a:txBody>
+                  <a:tcPr marL="7087" marR="7087" marT="7087" marB="0" anchor="ctr"/>
+                </a:tc>
+                <a:extLst>
+                  <a:ext uri="{0D108BD9-81ED-4DB2-BD59-A6C34878D82A}">
+                    <a16:rowId xmlns:a16="http://schemas.microsoft.com/office/drawing/2014/main" val="3849005551"/>
+                  </a:ext>
+                </a:extLst>
+              </a:tr>
+              <a:tr h="236442">
+                <a:tc>
+                  <a:txBody>
+                    <a:bodyPr/>
+                    <a:lstStyle/>
+                    <a:p>
+                      <a:pPr algn="ctr" fontAlgn="ctr">
+                        <a:buNone/>
+                      </a:pPr>
+                      <a:r>
+                        <a:rPr lang="en-US" sz="1100" u="none" strike="noStrike">
+                          <a:effectLst/>
+                        </a:rPr>
+                        <a:t>3.2</a:t>
+                      </a:r>
+                      <a:endParaRPr lang="en-US" sz="1100" b="0" i="0" u="none" strike="noStrike">
+                        <a:solidFill>
+                          <a:srgbClr val="000000"/>
+                        </a:solidFill>
+                        <a:effectLst/>
+                        <a:latin typeface="Times New Roman" panose="02020603050405020304" pitchFamily="18" charset="0"/>
+                      </a:endParaRPr>
+                    </a:p>
+                  </a:txBody>
+                  <a:tcPr marL="7087" marR="7087" marT="7087" marB="0" anchor="ctr"/>
+                </a:tc>
+                <a:tc>
+                  <a:txBody>
+                    <a:bodyPr/>
+                    <a:lstStyle/>
+                    <a:p>
+                      <a:pPr algn="l" fontAlgn="ctr">
+                        <a:buNone/>
+                      </a:pPr>
+                      <a:r>
+                        <a:rPr lang="en-US" sz="1100" u="none" strike="noStrike">
+                          <a:effectLst/>
+                        </a:rPr>
+                        <a:t>Gantt chart</a:t>
+                      </a:r>
+                      <a:endParaRPr lang="en-US" sz="1100" b="0" i="0" u="none" strike="noStrike">
+                        <a:solidFill>
+                          <a:srgbClr val="000000"/>
+                        </a:solidFill>
+                        <a:effectLst/>
+                        <a:latin typeface="Times New Roman" panose="02020603050405020304" pitchFamily="18" charset="0"/>
+                      </a:endParaRPr>
+                    </a:p>
+                  </a:txBody>
+                  <a:tcPr marL="63782" marR="7087" marT="7087" marB="0" anchor="ctr"/>
+                </a:tc>
+                <a:tc>
+                  <a:txBody>
+                    <a:bodyPr/>
+                    <a:lstStyle/>
+                    <a:p>
+                      <a:pPr algn="ctr" fontAlgn="ctr">
+                        <a:buNone/>
+                      </a:pPr>
+                      <a:r>
+                        <a:rPr lang="en-US" sz="1100" u="none" strike="noStrike">
+                          <a:effectLst/>
+                        </a:rPr>
+                        <a:t>18-May</a:t>
+                      </a:r>
+                      <a:endParaRPr lang="en-US" sz="1100" b="0" i="0" u="none" strike="noStrike">
+                        <a:solidFill>
+                          <a:srgbClr val="000000"/>
+                        </a:solidFill>
+                        <a:effectLst/>
+                        <a:latin typeface="Times New Roman" panose="02020603050405020304" pitchFamily="18" charset="0"/>
+                      </a:endParaRPr>
+                    </a:p>
+                  </a:txBody>
+                  <a:tcPr marL="7087" marR="7087" marT="7087" marB="0" anchor="ctr"/>
+                </a:tc>
+                <a:tc>
+                  <a:txBody>
+                    <a:bodyPr/>
+                    <a:lstStyle/>
+                    <a:p>
+                      <a:pPr algn="ctr" fontAlgn="ctr">
+                        <a:buNone/>
+                      </a:pPr>
+                      <a:r>
+                        <a:rPr lang="en-US" sz="1100" u="none" strike="noStrike">
+                          <a:effectLst/>
+                        </a:rPr>
+                        <a:t>18-May</a:t>
+                      </a:r>
+                      <a:endParaRPr lang="en-US" sz="1100" b="0" i="0" u="none" strike="noStrike">
+                        <a:solidFill>
+                          <a:srgbClr val="000000"/>
+                        </a:solidFill>
+                        <a:effectLst/>
+                        <a:latin typeface="Times New Roman" panose="02020603050405020304" pitchFamily="18" charset="0"/>
+                      </a:endParaRPr>
+                    </a:p>
+                  </a:txBody>
+                  <a:tcPr marL="7087" marR="7087" marT="7087" marB="0" anchor="ctr"/>
+                </a:tc>
+                <a:tc>
+                  <a:txBody>
+                    <a:bodyPr/>
+                    <a:lstStyle/>
+                    <a:p>
+                      <a:pPr algn="ctr" fontAlgn="ctr">
+                        <a:buNone/>
+                      </a:pPr>
+                      <a:r>
+                        <a:rPr lang="en-US" sz="1100" u="none" strike="noStrike">
+                          <a:effectLst/>
+                        </a:rPr>
+                        <a:t>1</a:t>
+                      </a:r>
+                      <a:endParaRPr lang="en-US" sz="1100" b="0" i="0" u="none" strike="noStrike">
+                        <a:solidFill>
+                          <a:srgbClr val="000000"/>
+                        </a:solidFill>
+                        <a:effectLst/>
+                        <a:latin typeface="Times New Roman" panose="02020603050405020304" pitchFamily="18" charset="0"/>
+                      </a:endParaRPr>
+                    </a:p>
+                  </a:txBody>
+                  <a:tcPr marL="7087" marR="7087" marT="7087" marB="0" anchor="ctr"/>
+                </a:tc>
+                <a:extLst>
+                  <a:ext uri="{0D108BD9-81ED-4DB2-BD59-A6C34878D82A}">
+                    <a16:rowId xmlns:a16="http://schemas.microsoft.com/office/drawing/2014/main" val="2246270999"/>
+                  </a:ext>
+                </a:extLst>
+              </a:tr>
+              <a:tr h="263723">
+                <a:tc>
+                  <a:txBody>
+                    <a:bodyPr/>
+                    <a:lstStyle/>
+                    <a:p>
+                      <a:pPr algn="ctr" fontAlgn="ctr">
+                        <a:buNone/>
+                      </a:pPr>
+                      <a:r>
+                        <a:rPr lang="en-US" sz="1100" u="none" strike="noStrike">
+                          <a:effectLst/>
+                        </a:rPr>
+                        <a:t>3.3</a:t>
+                      </a:r>
+                      <a:endParaRPr lang="en-US" sz="1100" b="0" i="0" u="none" strike="noStrike">
+                        <a:solidFill>
+                          <a:srgbClr val="FF0000"/>
+                        </a:solidFill>
+                        <a:effectLst/>
+                        <a:latin typeface="Times New Roman" panose="02020603050405020304" pitchFamily="18" charset="0"/>
+                      </a:endParaRPr>
+                    </a:p>
+                  </a:txBody>
+                  <a:tcPr marL="7087" marR="7087" marT="7087" marB="0" anchor="ctr"/>
+                </a:tc>
+                <a:tc>
+                  <a:txBody>
+                    <a:bodyPr/>
+                    <a:lstStyle/>
+                    <a:p>
+                      <a:pPr algn="l" fontAlgn="ctr">
+                        <a:buNone/>
+                      </a:pPr>
+                      <a:r>
+                        <a:rPr lang="en-US" sz="1100" u="none" strike="noStrike">
+                          <a:effectLst/>
+                        </a:rPr>
+                        <a:t>Project Start</a:t>
+                      </a:r>
+                      <a:endParaRPr lang="en-US" sz="1100" b="0" i="0" u="none" strike="noStrike">
+                        <a:solidFill>
+                          <a:srgbClr val="FF0000"/>
+                        </a:solidFill>
+                        <a:effectLst/>
+                        <a:latin typeface="Times New Roman" panose="02020603050405020304" pitchFamily="18" charset="0"/>
+                      </a:endParaRPr>
+                    </a:p>
+                  </a:txBody>
+                  <a:tcPr marL="63782" marR="7087" marT="7087" marB="0" anchor="ctr"/>
+                </a:tc>
+                <a:tc>
+                  <a:txBody>
+                    <a:bodyPr/>
+                    <a:lstStyle/>
+                    <a:p>
+                      <a:pPr algn="ctr" fontAlgn="ctr">
+                        <a:buNone/>
+                      </a:pPr>
+                      <a:r>
+                        <a:rPr lang="en-US" sz="1100" u="none" strike="noStrike">
+                          <a:effectLst/>
+                        </a:rPr>
+                        <a:t> </a:t>
+                      </a:r>
+                      <a:endParaRPr lang="en-US" sz="1100" b="0" i="0" u="none" strike="noStrike">
+                        <a:solidFill>
+                          <a:srgbClr val="000000"/>
+                        </a:solidFill>
+                        <a:effectLst/>
+                        <a:latin typeface="Times New Roman" panose="02020603050405020304" pitchFamily="18" charset="0"/>
+                      </a:endParaRPr>
+                    </a:p>
+                  </a:txBody>
+                  <a:tcPr marL="7087" marR="7087" marT="7087" marB="0" anchor="ctr"/>
+                </a:tc>
+                <a:tc>
+                  <a:txBody>
+                    <a:bodyPr/>
+                    <a:lstStyle/>
+                    <a:p>
+                      <a:pPr algn="ctr" fontAlgn="ctr">
+                        <a:buNone/>
+                      </a:pPr>
+                      <a:r>
+                        <a:rPr lang="en-US" sz="1100" u="none" strike="noStrike">
+                          <a:effectLst/>
+                        </a:rPr>
+                        <a:t> </a:t>
+                      </a:r>
+                      <a:endParaRPr lang="en-US" sz="1100" b="0" i="0" u="none" strike="noStrike">
+                        <a:solidFill>
+                          <a:srgbClr val="000000"/>
+                        </a:solidFill>
+                        <a:effectLst/>
+                        <a:latin typeface="Times New Roman" panose="02020603050405020304" pitchFamily="18" charset="0"/>
+                      </a:endParaRPr>
+                    </a:p>
+                  </a:txBody>
+                  <a:tcPr marL="7087" marR="7087" marT="7087" marB="0" anchor="ctr"/>
+                </a:tc>
+                <a:tc>
+                  <a:txBody>
+                    <a:bodyPr/>
+                    <a:lstStyle/>
+                    <a:p>
+                      <a:pPr algn="ctr" fontAlgn="ctr">
+                        <a:buNone/>
+                      </a:pPr>
+                      <a:r>
+                        <a:rPr lang="en-US" sz="1100" u="none" strike="noStrike">
+                          <a:effectLst/>
+                        </a:rPr>
+                        <a:t> </a:t>
+                      </a:r>
+                      <a:endParaRPr lang="en-US" sz="1100" b="0" i="0" u="none" strike="noStrike">
+                        <a:solidFill>
+                          <a:srgbClr val="000000"/>
+                        </a:solidFill>
+                        <a:effectLst/>
+                        <a:latin typeface="Times New Roman" panose="02020603050405020304" pitchFamily="18" charset="0"/>
+                      </a:endParaRPr>
+                    </a:p>
+                  </a:txBody>
+                  <a:tcPr marL="7087" marR="7087" marT="7087" marB="0" anchor="ctr"/>
+                </a:tc>
+                <a:extLst>
+                  <a:ext uri="{0D108BD9-81ED-4DB2-BD59-A6C34878D82A}">
+                    <a16:rowId xmlns:a16="http://schemas.microsoft.com/office/drawing/2014/main" val="3570580697"/>
+                  </a:ext>
+                </a:extLst>
+              </a:tr>
+              <a:tr h="318287">
+                <a:tc>
+                  <a:txBody>
+                    <a:bodyPr/>
+                    <a:lstStyle/>
+                    <a:p>
+                      <a:pPr algn="ctr" fontAlgn="ctr">
+                        <a:buNone/>
+                      </a:pPr>
+                      <a:r>
+                        <a:rPr lang="en-US" sz="1100" u="none" strike="noStrike">
+                          <a:effectLst/>
+                        </a:rPr>
+                        <a:t>3.3.1</a:t>
+                      </a:r>
+                      <a:endParaRPr lang="en-US" sz="1100" b="0" i="0" u="none" strike="noStrike">
+                        <a:solidFill>
+                          <a:srgbClr val="000000"/>
+                        </a:solidFill>
+                        <a:effectLst/>
+                        <a:latin typeface="Times New Roman" panose="02020603050405020304" pitchFamily="18" charset="0"/>
+                      </a:endParaRPr>
+                    </a:p>
+                  </a:txBody>
+                  <a:tcPr marL="7087" marR="7087" marT="7087" marB="0" anchor="ctr"/>
+                </a:tc>
+                <a:tc>
+                  <a:txBody>
+                    <a:bodyPr/>
+                    <a:lstStyle/>
+                    <a:p>
+                      <a:pPr algn="l" fontAlgn="ctr">
+                        <a:buNone/>
+                      </a:pPr>
+                      <a:r>
+                        <a:rPr lang="en-US" sz="1100" u="none" strike="noStrike">
+                          <a:effectLst/>
+                        </a:rPr>
+                        <a:t>Database Definition and Login/Signup Page</a:t>
+                      </a:r>
+                      <a:endParaRPr lang="en-US" sz="1100" b="0" i="0" u="none" strike="noStrike">
+                        <a:solidFill>
+                          <a:srgbClr val="000000"/>
+                        </a:solidFill>
+                        <a:effectLst/>
+                        <a:latin typeface="Times New Roman" panose="02020603050405020304" pitchFamily="18" charset="0"/>
+                      </a:endParaRPr>
+                    </a:p>
+                  </a:txBody>
+                  <a:tcPr marL="63782" marR="7087" marT="7087" marB="0" anchor="ctr"/>
+                </a:tc>
+                <a:tc>
+                  <a:txBody>
+                    <a:bodyPr/>
+                    <a:lstStyle/>
+                    <a:p>
+                      <a:pPr algn="ctr" fontAlgn="ctr">
+                        <a:buNone/>
+                      </a:pPr>
+                      <a:r>
+                        <a:rPr lang="en-US" sz="1100" u="none" strike="noStrike">
+                          <a:effectLst/>
+                        </a:rPr>
+                        <a:t>20-May</a:t>
+                      </a:r>
+                      <a:endParaRPr lang="en-US" sz="1100" b="0" i="0" u="none" strike="noStrike">
+                        <a:solidFill>
+                          <a:srgbClr val="000000"/>
+                        </a:solidFill>
+                        <a:effectLst/>
+                        <a:latin typeface="Times New Roman" panose="02020603050405020304" pitchFamily="18" charset="0"/>
+                      </a:endParaRPr>
+                    </a:p>
+                  </a:txBody>
+                  <a:tcPr marL="7087" marR="7087" marT="7087" marB="0" anchor="ctr"/>
+                </a:tc>
+                <a:tc>
+                  <a:txBody>
+                    <a:bodyPr/>
+                    <a:lstStyle/>
+                    <a:p>
+                      <a:pPr algn="ctr" fontAlgn="ctr">
+                        <a:buNone/>
+                      </a:pPr>
+                      <a:r>
+                        <a:rPr lang="en-US" sz="1100" u="none" strike="noStrike">
+                          <a:effectLst/>
+                        </a:rPr>
+                        <a:t>22-May</a:t>
+                      </a:r>
+                      <a:endParaRPr lang="en-US" sz="1100" b="0" i="0" u="none" strike="noStrike">
+                        <a:solidFill>
+                          <a:srgbClr val="000000"/>
+                        </a:solidFill>
+                        <a:effectLst/>
+                        <a:latin typeface="Times New Roman" panose="02020603050405020304" pitchFamily="18" charset="0"/>
+                      </a:endParaRPr>
+                    </a:p>
+                  </a:txBody>
+                  <a:tcPr marL="7087" marR="7087" marT="7087" marB="0" anchor="ctr"/>
+                </a:tc>
+                <a:tc>
+                  <a:txBody>
+                    <a:bodyPr/>
+                    <a:lstStyle/>
+                    <a:p>
+                      <a:pPr algn="ctr" fontAlgn="ctr">
+                        <a:buNone/>
+                      </a:pPr>
+                      <a:r>
+                        <a:rPr lang="en-US" sz="1100" u="none" strike="noStrike">
+                          <a:effectLst/>
+                        </a:rPr>
+                        <a:t>3</a:t>
+                      </a:r>
+                      <a:endParaRPr lang="en-US" sz="1100" b="0" i="0" u="none" strike="noStrike">
+                        <a:solidFill>
+                          <a:srgbClr val="000000"/>
+                        </a:solidFill>
+                        <a:effectLst/>
+                        <a:latin typeface="Times New Roman" panose="02020603050405020304" pitchFamily="18" charset="0"/>
+                      </a:endParaRPr>
+                    </a:p>
+                  </a:txBody>
+                  <a:tcPr marL="7087" marR="7087" marT="7087" marB="0" anchor="ctr"/>
+                </a:tc>
+                <a:extLst>
+                  <a:ext uri="{0D108BD9-81ED-4DB2-BD59-A6C34878D82A}">
+                    <a16:rowId xmlns:a16="http://schemas.microsoft.com/office/drawing/2014/main" val="1172700881"/>
+                  </a:ext>
+                </a:extLst>
+              </a:tr>
+              <a:tr h="236442">
+                <a:tc>
+                  <a:txBody>
+                    <a:bodyPr/>
+                    <a:lstStyle/>
+                    <a:p>
+                      <a:pPr algn="ctr" fontAlgn="ctr">
+                        <a:buNone/>
+                      </a:pPr>
+                      <a:r>
+                        <a:rPr lang="en-US" sz="1100" u="none" strike="noStrike">
+                          <a:effectLst/>
+                        </a:rPr>
+                        <a:t>3.3.2</a:t>
+                      </a:r>
+                      <a:endParaRPr lang="en-US" sz="1100" b="0" i="0" u="none" strike="noStrike">
+                        <a:solidFill>
+                          <a:srgbClr val="000000"/>
+                        </a:solidFill>
+                        <a:effectLst/>
+                        <a:latin typeface="Times New Roman" panose="02020603050405020304" pitchFamily="18" charset="0"/>
+                      </a:endParaRPr>
+                    </a:p>
+                  </a:txBody>
+                  <a:tcPr marL="7087" marR="7087" marT="7087" marB="0" anchor="ctr"/>
+                </a:tc>
+                <a:tc>
+                  <a:txBody>
+                    <a:bodyPr/>
+                    <a:lstStyle/>
+                    <a:p>
+                      <a:pPr algn="l" fontAlgn="ctr">
+                        <a:buNone/>
+                      </a:pPr>
+                      <a:r>
+                        <a:rPr lang="en-US" sz="1100" u="none" strike="noStrike">
+                          <a:effectLst/>
+                        </a:rPr>
+                        <a:t>User Dashboard and Admin Dashboard redirection</a:t>
+                      </a:r>
+                      <a:endParaRPr lang="en-US" sz="1100" b="0" i="0" u="none" strike="noStrike">
+                        <a:solidFill>
+                          <a:srgbClr val="000000"/>
+                        </a:solidFill>
+                        <a:effectLst/>
+                        <a:latin typeface="Times New Roman" panose="02020603050405020304" pitchFamily="18" charset="0"/>
+                      </a:endParaRPr>
+                    </a:p>
+                  </a:txBody>
+                  <a:tcPr marL="63782" marR="7087" marT="7087" marB="0" anchor="ctr"/>
+                </a:tc>
+                <a:tc>
+                  <a:txBody>
+                    <a:bodyPr/>
+                    <a:lstStyle/>
+                    <a:p>
+                      <a:pPr algn="ctr" fontAlgn="ctr">
+                        <a:buNone/>
+                      </a:pPr>
+                      <a:r>
+                        <a:rPr lang="en-US" sz="1100" u="none" strike="noStrike">
+                          <a:effectLst/>
+                        </a:rPr>
+                        <a:t>23-May</a:t>
+                      </a:r>
+                      <a:endParaRPr lang="en-US" sz="1100" b="0" i="0" u="none" strike="noStrike">
+                        <a:solidFill>
+                          <a:srgbClr val="000000"/>
+                        </a:solidFill>
+                        <a:effectLst/>
+                        <a:latin typeface="Times New Roman" panose="02020603050405020304" pitchFamily="18" charset="0"/>
+                      </a:endParaRPr>
+                    </a:p>
+                  </a:txBody>
+                  <a:tcPr marL="7087" marR="7087" marT="7087" marB="0" anchor="ctr"/>
+                </a:tc>
+                <a:tc>
+                  <a:txBody>
+                    <a:bodyPr/>
+                    <a:lstStyle/>
+                    <a:p>
+                      <a:pPr algn="ctr" fontAlgn="ctr">
+                        <a:buNone/>
+                      </a:pPr>
+                      <a:r>
+                        <a:rPr lang="en-US" sz="1100" u="none" strike="noStrike">
+                          <a:effectLst/>
+                        </a:rPr>
+                        <a:t>24-May</a:t>
+                      </a:r>
+                      <a:endParaRPr lang="en-US" sz="1100" b="0" i="0" u="none" strike="noStrike">
+                        <a:solidFill>
+                          <a:srgbClr val="000000"/>
+                        </a:solidFill>
+                        <a:effectLst/>
+                        <a:latin typeface="Times New Roman" panose="02020603050405020304" pitchFamily="18" charset="0"/>
+                      </a:endParaRPr>
+                    </a:p>
+                  </a:txBody>
+                  <a:tcPr marL="7087" marR="7087" marT="7087" marB="0" anchor="ctr"/>
+                </a:tc>
+                <a:tc>
+                  <a:txBody>
+                    <a:bodyPr/>
+                    <a:lstStyle/>
+                    <a:p>
+                      <a:pPr algn="ctr" fontAlgn="ctr">
+                        <a:buNone/>
+                      </a:pPr>
+                      <a:r>
+                        <a:rPr lang="en-US" sz="1100" u="none" strike="noStrike">
+                          <a:effectLst/>
+                        </a:rPr>
+                        <a:t>2</a:t>
+                      </a:r>
+                      <a:endParaRPr lang="en-US" sz="1100" b="0" i="0" u="none" strike="noStrike">
+                        <a:solidFill>
+                          <a:srgbClr val="000000"/>
+                        </a:solidFill>
+                        <a:effectLst/>
+                        <a:latin typeface="Times New Roman" panose="02020603050405020304" pitchFamily="18" charset="0"/>
+                      </a:endParaRPr>
+                    </a:p>
+                  </a:txBody>
+                  <a:tcPr marL="7087" marR="7087" marT="7087" marB="0" anchor="ctr"/>
+                </a:tc>
+                <a:extLst>
+                  <a:ext uri="{0D108BD9-81ED-4DB2-BD59-A6C34878D82A}">
+                    <a16:rowId xmlns:a16="http://schemas.microsoft.com/office/drawing/2014/main" val="506182568"/>
+                  </a:ext>
+                </a:extLst>
+              </a:tr>
+              <a:tr h="472884">
+                <a:tc>
+                  <a:txBody>
+                    <a:bodyPr/>
+                    <a:lstStyle/>
+                    <a:p>
+                      <a:pPr algn="ctr" fontAlgn="ctr">
+                        <a:buNone/>
+                      </a:pPr>
+                      <a:r>
+                        <a:rPr lang="en-US" sz="1100" u="none" strike="noStrike">
+                          <a:effectLst/>
+                        </a:rPr>
+                        <a:t>3.3.3</a:t>
+                      </a:r>
+                      <a:endParaRPr lang="en-US" sz="1100" b="0" i="0" u="none" strike="noStrike">
+                        <a:solidFill>
+                          <a:srgbClr val="000000"/>
+                        </a:solidFill>
+                        <a:effectLst/>
+                        <a:latin typeface="Times New Roman" panose="02020603050405020304" pitchFamily="18" charset="0"/>
+                      </a:endParaRPr>
+                    </a:p>
+                  </a:txBody>
+                  <a:tcPr marL="7087" marR="7087" marT="7087" marB="0" anchor="ctr"/>
+                </a:tc>
+                <a:tc>
+                  <a:txBody>
+                    <a:bodyPr/>
+                    <a:lstStyle/>
+                    <a:p>
+                      <a:pPr algn="l" fontAlgn="ctr">
+                        <a:buNone/>
+                      </a:pPr>
+                      <a:r>
+                        <a:rPr lang="en-US" sz="1100" u="none" strike="noStrike">
+                          <a:effectLst/>
+                        </a:rPr>
+                        <a:t>Order Menu creation(For users) and Admin custom menu for daily "Today's special" unique menu</a:t>
+                      </a:r>
+                      <a:endParaRPr lang="en-US" sz="1100" b="0" i="0" u="none" strike="noStrike">
+                        <a:solidFill>
+                          <a:srgbClr val="000000"/>
+                        </a:solidFill>
+                        <a:effectLst/>
+                        <a:latin typeface="Times New Roman" panose="02020603050405020304" pitchFamily="18" charset="0"/>
+                      </a:endParaRPr>
+                    </a:p>
+                  </a:txBody>
+                  <a:tcPr marL="63782" marR="7087" marT="7087" marB="0" anchor="ctr"/>
+                </a:tc>
+                <a:tc>
+                  <a:txBody>
+                    <a:bodyPr/>
+                    <a:lstStyle/>
+                    <a:p>
+                      <a:pPr algn="ctr" fontAlgn="ctr">
+                        <a:buNone/>
+                      </a:pPr>
+                      <a:r>
+                        <a:rPr lang="en-US" sz="1100" u="none" strike="noStrike">
+                          <a:effectLst/>
+                        </a:rPr>
+                        <a:t>26-May</a:t>
+                      </a:r>
+                      <a:endParaRPr lang="en-US" sz="1100" b="0" i="0" u="none" strike="noStrike">
+                        <a:solidFill>
+                          <a:srgbClr val="000000"/>
+                        </a:solidFill>
+                        <a:effectLst/>
+                        <a:latin typeface="Times New Roman" panose="02020603050405020304" pitchFamily="18" charset="0"/>
+                      </a:endParaRPr>
+                    </a:p>
+                  </a:txBody>
+                  <a:tcPr marL="7087" marR="7087" marT="7087" marB="0" anchor="ctr"/>
+                </a:tc>
+                <a:tc>
+                  <a:txBody>
+                    <a:bodyPr/>
+                    <a:lstStyle/>
+                    <a:p>
+                      <a:pPr algn="ctr" fontAlgn="ctr">
+                        <a:buNone/>
+                      </a:pPr>
+                      <a:r>
+                        <a:rPr lang="en-US" sz="1100" u="none" strike="noStrike">
+                          <a:effectLst/>
+                        </a:rPr>
+                        <a:t>28-May</a:t>
+                      </a:r>
+                      <a:endParaRPr lang="en-US" sz="1100" b="0" i="0" u="none" strike="noStrike">
+                        <a:solidFill>
+                          <a:srgbClr val="000000"/>
+                        </a:solidFill>
+                        <a:effectLst/>
+                        <a:latin typeface="Times New Roman" panose="02020603050405020304" pitchFamily="18" charset="0"/>
+                      </a:endParaRPr>
+                    </a:p>
+                  </a:txBody>
+                  <a:tcPr marL="7087" marR="7087" marT="7087" marB="0" anchor="ctr"/>
+                </a:tc>
+                <a:tc>
+                  <a:txBody>
+                    <a:bodyPr/>
+                    <a:lstStyle/>
+                    <a:p>
+                      <a:pPr algn="ctr" fontAlgn="ctr">
+                        <a:buNone/>
+                      </a:pPr>
+                      <a:r>
+                        <a:rPr lang="en-US" sz="1100" u="none" strike="noStrike">
+                          <a:effectLst/>
+                        </a:rPr>
+                        <a:t>3</a:t>
+                      </a:r>
+                      <a:endParaRPr lang="en-US" sz="1100" b="0" i="0" u="none" strike="noStrike">
+                        <a:solidFill>
+                          <a:srgbClr val="000000"/>
+                        </a:solidFill>
+                        <a:effectLst/>
+                        <a:latin typeface="Times New Roman" panose="02020603050405020304" pitchFamily="18" charset="0"/>
+                      </a:endParaRPr>
+                    </a:p>
+                  </a:txBody>
+                  <a:tcPr marL="7087" marR="7087" marT="7087" marB="0" anchor="ctr"/>
+                </a:tc>
+                <a:extLst>
+                  <a:ext uri="{0D108BD9-81ED-4DB2-BD59-A6C34878D82A}">
+                    <a16:rowId xmlns:a16="http://schemas.microsoft.com/office/drawing/2014/main" val="1457037831"/>
+                  </a:ext>
+                </a:extLst>
+              </a:tr>
+              <a:tr h="281911">
+                <a:tc>
+                  <a:txBody>
+                    <a:bodyPr/>
+                    <a:lstStyle/>
+                    <a:p>
+                      <a:pPr algn="ctr" fontAlgn="ctr">
+                        <a:buNone/>
+                      </a:pPr>
+                      <a:r>
+                        <a:rPr lang="en-US" sz="1100" u="none" strike="noStrike">
+                          <a:effectLst/>
+                        </a:rPr>
+                        <a:t>3.3.4</a:t>
+                      </a:r>
+                      <a:endParaRPr lang="en-US" sz="1100" b="0" i="0" u="none" strike="noStrike">
+                        <a:solidFill>
+                          <a:srgbClr val="000000"/>
+                        </a:solidFill>
+                        <a:effectLst/>
+                        <a:latin typeface="Times New Roman" panose="02020603050405020304" pitchFamily="18" charset="0"/>
+                      </a:endParaRPr>
+                    </a:p>
+                  </a:txBody>
+                  <a:tcPr marL="7087" marR="7087" marT="7087" marB="0" anchor="ctr"/>
+                </a:tc>
+                <a:tc>
+                  <a:txBody>
+                    <a:bodyPr/>
+                    <a:lstStyle/>
+                    <a:p>
+                      <a:pPr algn="l" fontAlgn="ctr">
+                        <a:buNone/>
+                      </a:pPr>
+                      <a:r>
+                        <a:rPr lang="en-US" sz="1100" u="none" strike="noStrike">
+                          <a:effectLst/>
+                        </a:rPr>
+                        <a:t>Order POST Logic and display order on admin side</a:t>
+                      </a:r>
+                      <a:endParaRPr lang="en-US" sz="1100" b="0" i="0" u="none" strike="noStrike">
+                        <a:solidFill>
+                          <a:srgbClr val="000000"/>
+                        </a:solidFill>
+                        <a:effectLst/>
+                        <a:latin typeface="Times New Roman" panose="02020603050405020304" pitchFamily="18" charset="0"/>
+                      </a:endParaRPr>
+                    </a:p>
+                  </a:txBody>
+                  <a:tcPr marL="63782" marR="7087" marT="7087" marB="0" anchor="ctr"/>
+                </a:tc>
+                <a:tc>
+                  <a:txBody>
+                    <a:bodyPr/>
+                    <a:lstStyle/>
+                    <a:p>
+                      <a:pPr algn="ctr" fontAlgn="ctr">
+                        <a:buNone/>
+                      </a:pPr>
+                      <a:r>
+                        <a:rPr lang="en-US" sz="1100" u="none" strike="noStrike">
+                          <a:effectLst/>
+                        </a:rPr>
+                        <a:t>28-May</a:t>
+                      </a:r>
+                      <a:endParaRPr lang="en-US" sz="1100" b="0" i="0" u="none" strike="noStrike">
+                        <a:solidFill>
+                          <a:srgbClr val="000000"/>
+                        </a:solidFill>
+                        <a:effectLst/>
+                        <a:latin typeface="Times New Roman" panose="02020603050405020304" pitchFamily="18" charset="0"/>
+                      </a:endParaRPr>
+                    </a:p>
+                  </a:txBody>
+                  <a:tcPr marL="7087" marR="7087" marT="7087" marB="0" anchor="ctr"/>
+                </a:tc>
+                <a:tc>
+                  <a:txBody>
+                    <a:bodyPr/>
+                    <a:lstStyle/>
+                    <a:p>
+                      <a:pPr algn="ctr" fontAlgn="ctr">
+                        <a:buNone/>
+                      </a:pPr>
+                      <a:r>
+                        <a:rPr lang="en-US" sz="1100" u="none" strike="noStrike">
+                          <a:effectLst/>
+                        </a:rPr>
+                        <a:t>29-May</a:t>
+                      </a:r>
+                      <a:endParaRPr lang="en-US" sz="1100" b="0" i="0" u="none" strike="noStrike">
+                        <a:solidFill>
+                          <a:srgbClr val="000000"/>
+                        </a:solidFill>
+                        <a:effectLst/>
+                        <a:latin typeface="Times New Roman" panose="02020603050405020304" pitchFamily="18" charset="0"/>
+                      </a:endParaRPr>
+                    </a:p>
+                  </a:txBody>
+                  <a:tcPr marL="7087" marR="7087" marT="7087" marB="0" anchor="ctr"/>
+                </a:tc>
+                <a:tc>
+                  <a:txBody>
+                    <a:bodyPr/>
+                    <a:lstStyle/>
+                    <a:p>
+                      <a:pPr algn="ctr" fontAlgn="ctr">
+                        <a:buNone/>
+                      </a:pPr>
+                      <a:r>
+                        <a:rPr lang="en-US" sz="1100" u="none" strike="noStrike">
+                          <a:effectLst/>
+                        </a:rPr>
+                        <a:t>2</a:t>
+                      </a:r>
+                      <a:endParaRPr lang="en-US" sz="1100" b="0" i="0" u="none" strike="noStrike">
+                        <a:solidFill>
+                          <a:srgbClr val="000000"/>
+                        </a:solidFill>
+                        <a:effectLst/>
+                        <a:latin typeface="Times New Roman" panose="02020603050405020304" pitchFamily="18" charset="0"/>
+                      </a:endParaRPr>
+                    </a:p>
+                  </a:txBody>
+                  <a:tcPr marL="7087" marR="7087" marT="7087" marB="0" anchor="ctr"/>
+                </a:tc>
+                <a:extLst>
+                  <a:ext uri="{0D108BD9-81ED-4DB2-BD59-A6C34878D82A}">
+                    <a16:rowId xmlns:a16="http://schemas.microsoft.com/office/drawing/2014/main" val="3977795001"/>
+                  </a:ext>
+                </a:extLst>
+              </a:tr>
+              <a:tr h="236442">
+                <a:tc>
+                  <a:txBody>
+                    <a:bodyPr/>
+                    <a:lstStyle/>
+                    <a:p>
+                      <a:pPr algn="ctr" fontAlgn="ctr">
+                        <a:buNone/>
+                      </a:pPr>
+                      <a:r>
+                        <a:rPr lang="en-US" sz="1100" u="none" strike="noStrike">
+                          <a:effectLst/>
+                        </a:rPr>
+                        <a:t>3.4</a:t>
+                      </a:r>
+                      <a:endParaRPr lang="en-US" sz="1100" b="0" i="0" u="none" strike="noStrike">
+                        <a:solidFill>
+                          <a:srgbClr val="000000"/>
+                        </a:solidFill>
+                        <a:effectLst/>
+                        <a:latin typeface="Times New Roman" panose="02020603050405020304" pitchFamily="18" charset="0"/>
+                      </a:endParaRPr>
+                    </a:p>
+                  </a:txBody>
+                  <a:tcPr marL="7087" marR="7087" marT="7087" marB="0" anchor="ctr"/>
+                </a:tc>
+                <a:tc>
+                  <a:txBody>
+                    <a:bodyPr/>
+                    <a:lstStyle/>
+                    <a:p>
+                      <a:pPr algn="l" fontAlgn="ctr">
+                        <a:buNone/>
+                      </a:pPr>
+                      <a:r>
+                        <a:rPr lang="en-US" sz="1100" u="none" strike="noStrike">
+                          <a:effectLst/>
+                        </a:rPr>
+                        <a:t>Testing and Test Case Creation</a:t>
+                      </a:r>
+                      <a:endParaRPr lang="en-US" sz="1100" b="0" i="0" u="none" strike="noStrike">
+                        <a:solidFill>
+                          <a:srgbClr val="000000"/>
+                        </a:solidFill>
+                        <a:effectLst/>
+                        <a:latin typeface="Times New Roman" panose="02020603050405020304" pitchFamily="18" charset="0"/>
+                      </a:endParaRPr>
+                    </a:p>
+                  </a:txBody>
+                  <a:tcPr marL="63782" marR="7087" marT="7087" marB="0" anchor="ctr"/>
+                </a:tc>
+                <a:tc>
+                  <a:txBody>
+                    <a:bodyPr/>
+                    <a:lstStyle/>
+                    <a:p>
+                      <a:pPr algn="ctr" fontAlgn="ctr">
+                        <a:buNone/>
+                      </a:pPr>
+                      <a:r>
+                        <a:rPr lang="en-US" sz="1100" u="none" strike="noStrike">
+                          <a:effectLst/>
+                        </a:rPr>
+                        <a:t>30-May</a:t>
+                      </a:r>
+                      <a:endParaRPr lang="en-US" sz="1100" b="0" i="0" u="none" strike="noStrike">
+                        <a:solidFill>
+                          <a:srgbClr val="000000"/>
+                        </a:solidFill>
+                        <a:effectLst/>
+                        <a:latin typeface="Times New Roman" panose="02020603050405020304" pitchFamily="18" charset="0"/>
+                      </a:endParaRPr>
+                    </a:p>
+                  </a:txBody>
+                  <a:tcPr marL="7087" marR="7087" marT="7087" marB="0" anchor="ctr"/>
+                </a:tc>
+                <a:tc>
+                  <a:txBody>
+                    <a:bodyPr/>
+                    <a:lstStyle/>
+                    <a:p>
+                      <a:pPr algn="ctr" fontAlgn="ctr">
+                        <a:buNone/>
+                      </a:pPr>
+                      <a:r>
+                        <a:rPr lang="en-US" sz="1100" u="none" strike="noStrike">
+                          <a:effectLst/>
+                        </a:rPr>
+                        <a:t>02-Jun</a:t>
+                      </a:r>
+                      <a:endParaRPr lang="en-US" sz="1100" b="0" i="0" u="none" strike="noStrike">
+                        <a:solidFill>
+                          <a:srgbClr val="000000"/>
+                        </a:solidFill>
+                        <a:effectLst/>
+                        <a:latin typeface="Times New Roman" panose="02020603050405020304" pitchFamily="18" charset="0"/>
+                      </a:endParaRPr>
+                    </a:p>
+                  </a:txBody>
+                  <a:tcPr marL="7087" marR="7087" marT="7087" marB="0" anchor="ctr"/>
+                </a:tc>
+                <a:tc>
+                  <a:txBody>
+                    <a:bodyPr/>
+                    <a:lstStyle/>
+                    <a:p>
+                      <a:pPr algn="ctr" fontAlgn="ctr">
+                        <a:buNone/>
+                      </a:pPr>
+                      <a:r>
+                        <a:rPr lang="en-US" sz="1100" u="none" strike="noStrike">
+                          <a:effectLst/>
+                        </a:rPr>
+                        <a:t>4</a:t>
+                      </a:r>
+                      <a:endParaRPr lang="en-US" sz="1100" b="0" i="0" u="none" strike="noStrike">
+                        <a:solidFill>
+                          <a:srgbClr val="000000"/>
+                        </a:solidFill>
+                        <a:effectLst/>
+                        <a:latin typeface="Times New Roman" panose="02020603050405020304" pitchFamily="18" charset="0"/>
+                      </a:endParaRPr>
+                    </a:p>
+                  </a:txBody>
+                  <a:tcPr marL="7087" marR="7087" marT="7087" marB="0" anchor="ctr"/>
+                </a:tc>
+                <a:extLst>
+                  <a:ext uri="{0D108BD9-81ED-4DB2-BD59-A6C34878D82A}">
+                    <a16:rowId xmlns:a16="http://schemas.microsoft.com/office/drawing/2014/main" val="1843064482"/>
+                  </a:ext>
+                </a:extLst>
+              </a:tr>
+              <a:tr h="236442">
+                <a:tc>
+                  <a:txBody>
+                    <a:bodyPr/>
+                    <a:lstStyle/>
+                    <a:p>
+                      <a:pPr algn="ctr" fontAlgn="ctr">
+                        <a:buNone/>
+                      </a:pPr>
+                      <a:r>
+                        <a:rPr lang="en-US" sz="1100" u="none" strike="noStrike">
+                          <a:effectLst/>
+                        </a:rPr>
+                        <a:t>3.5</a:t>
+                      </a:r>
+                      <a:endParaRPr lang="en-US" sz="1100" b="0" i="0" u="none" strike="noStrike">
+                        <a:solidFill>
+                          <a:srgbClr val="000000"/>
+                        </a:solidFill>
+                        <a:effectLst/>
+                        <a:latin typeface="Times New Roman" panose="02020603050405020304" pitchFamily="18" charset="0"/>
+                      </a:endParaRPr>
+                    </a:p>
+                  </a:txBody>
+                  <a:tcPr marL="7087" marR="7087" marT="7087" marB="0" anchor="ctr"/>
+                </a:tc>
+                <a:tc>
+                  <a:txBody>
+                    <a:bodyPr/>
+                    <a:lstStyle/>
+                    <a:p>
+                      <a:pPr algn="l" fontAlgn="ctr">
+                        <a:buNone/>
+                      </a:pPr>
+                      <a:r>
+                        <a:rPr lang="en-US" sz="1100" u="none" strike="noStrike">
+                          <a:effectLst/>
+                        </a:rPr>
+                        <a:t>Documentation Correction</a:t>
+                      </a:r>
+                      <a:endParaRPr lang="en-US" sz="1100" b="0" i="0" u="none" strike="noStrike">
+                        <a:solidFill>
+                          <a:srgbClr val="000000"/>
+                        </a:solidFill>
+                        <a:effectLst/>
+                        <a:latin typeface="Times New Roman" panose="02020603050405020304" pitchFamily="18" charset="0"/>
+                      </a:endParaRPr>
+                    </a:p>
+                  </a:txBody>
+                  <a:tcPr marL="63782" marR="7087" marT="7087" marB="0" anchor="ctr"/>
+                </a:tc>
+                <a:tc>
+                  <a:txBody>
+                    <a:bodyPr/>
+                    <a:lstStyle/>
+                    <a:p>
+                      <a:pPr algn="ctr" fontAlgn="ctr">
+                        <a:buNone/>
+                      </a:pPr>
+                      <a:r>
+                        <a:rPr lang="en-US" sz="1100" u="none" strike="noStrike">
+                          <a:effectLst/>
+                        </a:rPr>
+                        <a:t>03-Jun</a:t>
+                      </a:r>
+                      <a:endParaRPr lang="en-US" sz="1100" b="0" i="0" u="none" strike="noStrike">
+                        <a:solidFill>
+                          <a:srgbClr val="000000"/>
+                        </a:solidFill>
+                        <a:effectLst/>
+                        <a:latin typeface="Times New Roman" panose="02020603050405020304" pitchFamily="18" charset="0"/>
+                      </a:endParaRPr>
+                    </a:p>
+                  </a:txBody>
+                  <a:tcPr marL="7087" marR="7087" marT="7087" marB="0" anchor="ctr"/>
+                </a:tc>
+                <a:tc>
+                  <a:txBody>
+                    <a:bodyPr/>
+                    <a:lstStyle/>
+                    <a:p>
+                      <a:pPr algn="ctr" fontAlgn="ctr">
+                        <a:buNone/>
+                      </a:pPr>
+                      <a:r>
+                        <a:rPr lang="en-US" sz="1100" u="none" strike="noStrike">
+                          <a:effectLst/>
+                        </a:rPr>
+                        <a:t>04-Jun</a:t>
+                      </a:r>
+                      <a:endParaRPr lang="en-US" sz="1100" b="0" i="0" u="none" strike="noStrike">
+                        <a:solidFill>
+                          <a:srgbClr val="000000"/>
+                        </a:solidFill>
+                        <a:effectLst/>
+                        <a:latin typeface="Times New Roman" panose="02020603050405020304" pitchFamily="18" charset="0"/>
+                      </a:endParaRPr>
+                    </a:p>
+                  </a:txBody>
+                  <a:tcPr marL="7087" marR="7087" marT="7087" marB="0" anchor="ctr"/>
+                </a:tc>
+                <a:tc>
+                  <a:txBody>
+                    <a:bodyPr/>
+                    <a:lstStyle/>
+                    <a:p>
+                      <a:pPr algn="ctr" fontAlgn="ctr">
+                        <a:buNone/>
+                      </a:pPr>
+                      <a:r>
+                        <a:rPr lang="en-US" sz="1100" u="none" strike="noStrike">
+                          <a:effectLst/>
+                        </a:rPr>
+                        <a:t>2</a:t>
+                      </a:r>
+                      <a:endParaRPr lang="en-US" sz="1100" b="0" i="0" u="none" strike="noStrike">
+                        <a:solidFill>
+                          <a:srgbClr val="000000"/>
+                        </a:solidFill>
+                        <a:effectLst/>
+                        <a:latin typeface="Times New Roman" panose="02020603050405020304" pitchFamily="18" charset="0"/>
+                      </a:endParaRPr>
+                    </a:p>
+                  </a:txBody>
+                  <a:tcPr marL="7087" marR="7087" marT="7087" marB="0" anchor="ctr"/>
+                </a:tc>
+                <a:extLst>
+                  <a:ext uri="{0D108BD9-81ED-4DB2-BD59-A6C34878D82A}">
+                    <a16:rowId xmlns:a16="http://schemas.microsoft.com/office/drawing/2014/main" val="2196696537"/>
+                  </a:ext>
+                </a:extLst>
+              </a:tr>
+              <a:tr h="236442">
+                <a:tc>
+                  <a:txBody>
+                    <a:bodyPr/>
+                    <a:lstStyle/>
+                    <a:p>
+                      <a:pPr algn="ctr" fontAlgn="ctr">
+                        <a:buNone/>
+                      </a:pPr>
+                      <a:r>
+                        <a:rPr lang="en-US" sz="1100" u="none" strike="noStrike">
+                          <a:effectLst/>
+                        </a:rPr>
+                        <a:t>3.6</a:t>
+                      </a:r>
+                      <a:endParaRPr lang="en-US" sz="1100" b="0" i="0" u="none" strike="noStrike">
+                        <a:solidFill>
+                          <a:srgbClr val="000000"/>
+                        </a:solidFill>
+                        <a:effectLst/>
+                        <a:latin typeface="Times New Roman" panose="02020603050405020304" pitchFamily="18" charset="0"/>
+                      </a:endParaRPr>
+                    </a:p>
+                  </a:txBody>
+                  <a:tcPr marL="7087" marR="7087" marT="7087" marB="0" anchor="ctr"/>
+                </a:tc>
+                <a:tc>
+                  <a:txBody>
+                    <a:bodyPr/>
+                    <a:lstStyle/>
+                    <a:p>
+                      <a:pPr algn="l" fontAlgn="ctr">
+                        <a:buNone/>
+                      </a:pPr>
+                      <a:r>
+                        <a:rPr lang="en-US" sz="1100" u="none" strike="noStrike">
+                          <a:effectLst/>
+                        </a:rPr>
+                        <a:t>Documentation for Mid-Term Defense Creation</a:t>
+                      </a:r>
+                      <a:endParaRPr lang="en-US" sz="1100" b="0" i="0" u="none" strike="noStrike">
+                        <a:solidFill>
+                          <a:srgbClr val="000000"/>
+                        </a:solidFill>
+                        <a:effectLst/>
+                        <a:latin typeface="Times New Roman" panose="02020603050405020304" pitchFamily="18" charset="0"/>
+                      </a:endParaRPr>
+                    </a:p>
+                  </a:txBody>
+                  <a:tcPr marL="63782" marR="7087" marT="7087" marB="0" anchor="ctr"/>
+                </a:tc>
+                <a:tc>
+                  <a:txBody>
+                    <a:bodyPr/>
+                    <a:lstStyle/>
+                    <a:p>
+                      <a:pPr algn="ctr" fontAlgn="ctr">
+                        <a:buNone/>
+                      </a:pPr>
+                      <a:r>
+                        <a:rPr lang="en-US" sz="1100" u="none" strike="noStrike">
+                          <a:effectLst/>
+                        </a:rPr>
+                        <a:t>05-Jun</a:t>
+                      </a:r>
+                      <a:endParaRPr lang="en-US" sz="1100" b="0" i="0" u="none" strike="noStrike">
+                        <a:solidFill>
+                          <a:srgbClr val="000000"/>
+                        </a:solidFill>
+                        <a:effectLst/>
+                        <a:latin typeface="Times New Roman" panose="02020603050405020304" pitchFamily="18" charset="0"/>
+                      </a:endParaRPr>
+                    </a:p>
+                  </a:txBody>
+                  <a:tcPr marL="7087" marR="7087" marT="7087" marB="0" anchor="ctr"/>
+                </a:tc>
+                <a:tc>
+                  <a:txBody>
+                    <a:bodyPr/>
+                    <a:lstStyle/>
+                    <a:p>
+                      <a:pPr algn="ctr" fontAlgn="ctr">
+                        <a:buNone/>
+                      </a:pPr>
+                      <a:r>
+                        <a:rPr lang="en-US" sz="1100" u="none" strike="noStrike">
+                          <a:effectLst/>
+                        </a:rPr>
+                        <a:t>08-Jun</a:t>
+                      </a:r>
+                      <a:endParaRPr lang="en-US" sz="1100" b="0" i="0" u="none" strike="noStrike">
+                        <a:solidFill>
+                          <a:srgbClr val="000000"/>
+                        </a:solidFill>
+                        <a:effectLst/>
+                        <a:latin typeface="Times New Roman" panose="02020603050405020304" pitchFamily="18" charset="0"/>
+                      </a:endParaRPr>
+                    </a:p>
+                  </a:txBody>
+                  <a:tcPr marL="7087" marR="7087" marT="7087" marB="0" anchor="ctr"/>
+                </a:tc>
+                <a:tc>
+                  <a:txBody>
+                    <a:bodyPr/>
+                    <a:lstStyle/>
+                    <a:p>
+                      <a:pPr algn="ctr" fontAlgn="ctr">
+                        <a:buNone/>
+                      </a:pPr>
+                      <a:r>
+                        <a:rPr lang="en-US" sz="1100" u="none" strike="noStrike">
+                          <a:effectLst/>
+                        </a:rPr>
+                        <a:t>4</a:t>
+                      </a:r>
+                      <a:endParaRPr lang="en-US" sz="1100" b="0" i="0" u="none" strike="noStrike">
+                        <a:solidFill>
+                          <a:srgbClr val="000000"/>
+                        </a:solidFill>
+                        <a:effectLst/>
+                        <a:latin typeface="Times New Roman" panose="02020603050405020304" pitchFamily="18" charset="0"/>
+                      </a:endParaRPr>
+                    </a:p>
+                  </a:txBody>
+                  <a:tcPr marL="7087" marR="7087" marT="7087" marB="0" anchor="ctr"/>
+                </a:tc>
+                <a:extLst>
+                  <a:ext uri="{0D108BD9-81ED-4DB2-BD59-A6C34878D82A}">
+                    <a16:rowId xmlns:a16="http://schemas.microsoft.com/office/drawing/2014/main" val="844591366"/>
+                  </a:ext>
+                </a:extLst>
+              </a:tr>
+              <a:tr h="236442">
+                <a:tc>
+                  <a:txBody>
+                    <a:bodyPr/>
+                    <a:lstStyle/>
+                    <a:p>
+                      <a:pPr algn="ctr" fontAlgn="ctr">
+                        <a:buNone/>
+                      </a:pPr>
+                      <a:r>
+                        <a:rPr lang="en-US" sz="1100" u="none" strike="noStrike">
+                          <a:effectLst/>
+                        </a:rPr>
+                        <a:t>3.7</a:t>
+                      </a:r>
+                      <a:endParaRPr lang="en-US" sz="1100" b="0" i="0" u="none" strike="noStrike">
+                        <a:solidFill>
+                          <a:srgbClr val="000000"/>
+                        </a:solidFill>
+                        <a:effectLst/>
+                        <a:latin typeface="Times New Roman" panose="02020603050405020304" pitchFamily="18" charset="0"/>
+                      </a:endParaRPr>
+                    </a:p>
+                  </a:txBody>
+                  <a:tcPr marL="7087" marR="7087" marT="7087" marB="0" anchor="ctr"/>
+                </a:tc>
+                <a:tc>
+                  <a:txBody>
+                    <a:bodyPr/>
+                    <a:lstStyle/>
+                    <a:p>
+                      <a:pPr algn="l" fontAlgn="ctr">
+                        <a:buNone/>
+                      </a:pPr>
+                      <a:r>
+                        <a:rPr lang="en-US" sz="1100" u="none" strike="noStrike">
+                          <a:effectLst/>
+                        </a:rPr>
+                        <a:t>Presentation Preparation and Division</a:t>
+                      </a:r>
+                      <a:endParaRPr lang="en-US" sz="1100" b="0" i="0" u="none" strike="noStrike">
+                        <a:solidFill>
+                          <a:srgbClr val="000000"/>
+                        </a:solidFill>
+                        <a:effectLst/>
+                        <a:latin typeface="Times New Roman" panose="02020603050405020304" pitchFamily="18" charset="0"/>
+                      </a:endParaRPr>
+                    </a:p>
+                  </a:txBody>
+                  <a:tcPr marL="63782" marR="7087" marT="7087" marB="0" anchor="ctr"/>
+                </a:tc>
+                <a:tc>
+                  <a:txBody>
+                    <a:bodyPr/>
+                    <a:lstStyle/>
+                    <a:p>
+                      <a:pPr algn="ctr" fontAlgn="ctr">
+                        <a:buNone/>
+                      </a:pPr>
+                      <a:r>
+                        <a:rPr lang="en-US" sz="1100" u="none" strike="noStrike">
+                          <a:effectLst/>
+                        </a:rPr>
+                        <a:t>12-Jun</a:t>
+                      </a:r>
+                      <a:endParaRPr lang="en-US" sz="1100" b="0" i="0" u="none" strike="noStrike">
+                        <a:solidFill>
+                          <a:srgbClr val="000000"/>
+                        </a:solidFill>
+                        <a:effectLst/>
+                        <a:latin typeface="Times New Roman" panose="02020603050405020304" pitchFamily="18" charset="0"/>
+                      </a:endParaRPr>
+                    </a:p>
+                  </a:txBody>
+                  <a:tcPr marL="7087" marR="7087" marT="7087" marB="0" anchor="ctr"/>
+                </a:tc>
+                <a:tc>
+                  <a:txBody>
+                    <a:bodyPr/>
+                    <a:lstStyle/>
+                    <a:p>
+                      <a:pPr algn="ctr" fontAlgn="ctr">
+                        <a:buNone/>
+                      </a:pPr>
+                      <a:r>
+                        <a:rPr lang="en-US" sz="1100" u="none" strike="noStrike">
+                          <a:effectLst/>
+                        </a:rPr>
+                        <a:t>13-Jun</a:t>
+                      </a:r>
+                      <a:endParaRPr lang="en-US" sz="1100" b="0" i="0" u="none" strike="noStrike">
+                        <a:solidFill>
+                          <a:srgbClr val="000000"/>
+                        </a:solidFill>
+                        <a:effectLst/>
+                        <a:latin typeface="Times New Roman" panose="02020603050405020304" pitchFamily="18" charset="0"/>
+                      </a:endParaRPr>
+                    </a:p>
+                  </a:txBody>
+                  <a:tcPr marL="7087" marR="7087" marT="7087" marB="0" anchor="ctr"/>
+                </a:tc>
+                <a:tc>
+                  <a:txBody>
+                    <a:bodyPr/>
+                    <a:lstStyle/>
+                    <a:p>
+                      <a:pPr algn="ctr" fontAlgn="ctr">
+                        <a:buNone/>
+                      </a:pPr>
+                      <a:r>
+                        <a:rPr lang="en-US" sz="1100" u="none" strike="noStrike" dirty="0">
+                          <a:effectLst/>
+                        </a:rPr>
+                        <a:t>2</a:t>
+                      </a:r>
+                      <a:endParaRPr lang="en-US" sz="1100" b="0" i="0" u="none" strike="noStrike" dirty="0">
+                        <a:solidFill>
+                          <a:srgbClr val="000000"/>
+                        </a:solidFill>
+                        <a:effectLst/>
+                        <a:latin typeface="Times New Roman" panose="02020603050405020304" pitchFamily="18" charset="0"/>
+                      </a:endParaRPr>
+                    </a:p>
+                  </a:txBody>
+                  <a:tcPr marL="7087" marR="7087" marT="7087" marB="0" anchor="ctr"/>
+                </a:tc>
+                <a:extLst>
+                  <a:ext uri="{0D108BD9-81ED-4DB2-BD59-A6C34878D82A}">
+                    <a16:rowId xmlns:a16="http://schemas.microsoft.com/office/drawing/2014/main" val="3773212025"/>
+                  </a:ext>
+                </a:extLst>
+              </a:tr>
+            </a:tbl>
+          </a:graphicData>
+        </a:graphic>
+      </p:graphicFrame>
     </p:spTree>
     <p:extLst>
       <p:ext uri="{BB962C8B-B14F-4D97-AF65-F5344CB8AC3E}">
@@ -4259,7 +7203,7 @@
           <a:p>
             <a:r>
               <a:rPr lang="en-US" dirty="0"/>
-              <a:t>Git and GitHub for collaborations</a:t>
+              <a:t>Git and GitHub for collaborations and backlog</a:t>
             </a:r>
           </a:p>
           <a:p>

</xml_diff>